<commit_message>
Ultima version de slides
</commit_message>
<xml_diff>
--- a/Slides_IA_AWS_UG_Cucuta.pptx
+++ b/Slides_IA_AWS_UG_Cucuta.pptx
@@ -44,8 +44,8 @@
     <p:sldId id="289" r:id="rId35"/>
     <p:sldId id="290" r:id="rId36"/>
     <p:sldId id="291" r:id="rId37"/>
-    <p:sldId id="292" r:id="rId38"/>
-    <p:sldId id="293" r:id="rId39"/>
+    <p:sldId id="293" r:id="rId38"/>
+    <p:sldId id="292" r:id="rId39"/>
   </p:sldIdLst>
   <p:sldSz cx="12192000" cy="6858000"/>
   <p:notesSz cx="6858000" cy="12192000"/>
@@ -3259,13 +3259,7 @@
               <a:t>[6.4 Última frase]  38:48–39:58
 CIERRE
 ----------------------------------------
-Quizás dentro de algunos años escribamos mucho menos código a mano.
-Pero eso no significa que necesitemos menos ingeniería.
-Probablemente necesitemos más.
-Porque cuando cualquiera puede producir software, la diferencia entre producir código y construir un buen sistema se vuelve todavía más importante.
-&gt;&gt; Pausa. Última línea, más lento, mirando al público.
-Así que no tengan miedo de que la inteligencia artificial aprenda a programar.
-Preocúpense por aprender ustedes a hacer ingeniería.</a:t>
+</a:t>
             </a:r>
           </a:p>
         </p:txBody>
@@ -3355,7 +3349,13 @@
               <a:t>[6.4 Última frase]  38:48–39:58
 CIERRE
 ----------------------------------------
-</a:t>
+Quizás dentro de algunos años escribamos mucho menos código a mano.
+Pero eso no significa que necesitemos menos ingeniería.
+Probablemente necesitemos más.
+Porque cuando cualquiera puede producir software, la diferencia entre producir código y construir un buen sistema se vuelve todavía más importante.
+&gt;&gt; Pausa. Última línea, más lento, mirando al público.
+Así que no tengan miedo de que la inteligencia artificial aprenda a programar.
+Preocúpense por aprender ustedes a hacer ingeniería.</a:t>
             </a:r>
           </a:p>
         </p:txBody>
@@ -5055,574 +5055,674 @@
           </a:p>
         </p:txBody>
       </p:sp>
-      <p:sp>
-        <p:nvSpPr>
-          <p:cNvPr id="8" name="Shape 4"/>
-          <p:cNvSpPr/>
-          <p:nvPr/>
-        </p:nvSpPr>
-        <p:spPr>
+      <p:grpSp>
+        <p:nvGrpSpPr>
+          <p:cNvPr id="2" name="Group 1">
+            <a:extLst>
+              <a:ext uri="{FF2B5EF4-FFF2-40B4-BE49-F238E27FC236}">
+                <a16:creationId xmlns:a16="http://schemas.microsoft.com/office/drawing/2014/main" id="{B7642012-B655-6E83-F8D9-39569832E10D}"/>
+              </a:ext>
+            </a:extLst>
+          </p:cNvPr>
+          <p:cNvGrpSpPr/>
+          <p:nvPr/>
+        </p:nvGrpSpPr>
+        <p:grpSpPr>
           <a:xfrm>
             <a:off x="822960" y="2103120"/>
             <a:ext cx="2396414" cy="3529584"/>
-          </a:xfrm>
-          <a:prstGeom prst="rect">
-            <a:avLst/>
-          </a:prstGeom>
-          <a:solidFill>
-            <a:srgbClr val="1E2739"/>
-          </a:solidFill>
-          <a:ln w="12700">
+            <a:chOff x="822960" y="2103120"/>
+            <a:chExt cx="2396414" cy="3529584"/>
+          </a:xfrm>
+        </p:grpSpPr>
+        <p:sp>
+          <p:nvSpPr>
+            <p:cNvPr id="8" name="Shape 4"/>
+            <p:cNvSpPr/>
+            <p:nvPr/>
+          </p:nvSpPr>
+          <p:spPr>
+            <a:xfrm>
+              <a:off x="822960" y="2103120"/>
+              <a:ext cx="2396414" cy="3529584"/>
+            </a:xfrm>
+            <a:prstGeom prst="rect">
+              <a:avLst/>
+            </a:prstGeom>
             <a:solidFill>
-              <a:srgbClr val="2C3852"/>
+              <a:srgbClr val="1E2739"/>
             </a:solidFill>
-            <a:prstDash val="solid"/>
-          </a:ln>
-        </p:spPr>
-        <p:txBody>
-          <a:bodyPr/>
-          <a:lstStyle/>
-          <a:p>
-            <a:endParaRPr lang="en-CO"/>
-          </a:p>
-        </p:txBody>
-      </p:sp>
-      <p:sp>
-        <p:nvSpPr>
-          <p:cNvPr id="9" name="Text 5"/>
-          <p:cNvSpPr/>
-          <p:nvPr/>
-        </p:nvSpPr>
-        <p:spPr>
-          <a:xfrm>
-            <a:off x="1143000" y="2423160"/>
-            <a:ext cx="1756334" cy="320040"/>
-          </a:xfrm>
-          <a:prstGeom prst="rect">
-            <a:avLst/>
-          </a:prstGeom>
-          <a:noFill/>
-          <a:ln/>
-        </p:spPr>
-        <p:txBody>
-          <a:bodyPr wrap="square" lIns="0" tIns="0" rIns="0" bIns="0" rtlCol="0" anchor="ctr"/>
-          <a:lstStyle/>
-          <a:p>
-            <a:pPr marL="0" indent="0">
-              <a:buNone/>
-            </a:pPr>
-            <a:r>
-              <a:rPr lang="en-US" sz="1200" b="1" kern="0" spc="200" dirty="0">
-                <a:solidFill>
-                  <a:srgbClr val="9257F1"/>
-                </a:solidFill>
-                <a:latin typeface="Arial" pitchFamily="34" charset="0"/>
-                <a:ea typeface="Arial" pitchFamily="34" charset="-122"/>
-                <a:cs typeface="Arial" pitchFamily="34" charset="-120"/>
-              </a:rPr>
-              <a:t>1</a:t>
-            </a:r>
-            <a:endParaRPr lang="en-US" sz="1200" dirty="0"/>
-          </a:p>
-        </p:txBody>
-      </p:sp>
-      <p:sp>
-        <p:nvSpPr>
-          <p:cNvPr id="10" name="Text 6"/>
-          <p:cNvSpPr/>
-          <p:nvPr/>
-        </p:nvSpPr>
-        <p:spPr>
-          <a:xfrm>
-            <a:off x="1143000" y="2880360"/>
-            <a:ext cx="1756334" cy="2148840"/>
-          </a:xfrm>
-          <a:prstGeom prst="rect">
-            <a:avLst/>
-          </a:prstGeom>
-          <a:noFill/>
-          <a:ln/>
-        </p:spPr>
-        <p:txBody>
-          <a:bodyPr wrap="square" lIns="0" tIns="0" rIns="0" bIns="0" rtlCol="0" anchor="t"/>
-          <a:lstStyle/>
-          <a:p>
-            <a:pPr marL="0" indent="0">
-              <a:lnSpc>
-                <a:spcPts val="2600"/>
-              </a:lnSpc>
-              <a:buNone/>
-            </a:pPr>
-            <a:r>
-              <a:rPr lang="en-US" sz="1500" dirty="0">
-                <a:solidFill>
-                  <a:srgbClr val="FFFFFF"/>
-                </a:solidFill>
-                <a:latin typeface="Arial" pitchFamily="34" charset="0"/>
-                <a:ea typeface="Arial" pitchFamily="34" charset="-122"/>
-                <a:cs typeface="Arial" pitchFamily="34" charset="-120"/>
-              </a:rPr>
-              <a:t>Hablar con la máquina</a:t>
-            </a:r>
-            <a:endParaRPr lang="en-US" sz="1500" dirty="0"/>
-          </a:p>
-          <a:p>
-            <a:pPr marL="0" indent="0">
-              <a:lnSpc>
-                <a:spcPts val="2600"/>
-              </a:lnSpc>
-              <a:buNone/>
-            </a:pPr>
-            <a:endParaRPr lang="en-US" sz="1500" dirty="0"/>
-          </a:p>
-          <a:p>
-            <a:pPr marL="0" indent="0">
-              <a:lnSpc>
-                <a:spcPts val="2600"/>
-              </a:lnSpc>
-              <a:buNone/>
-            </a:pPr>
-            <a:r>
-              <a:rPr lang="en-US" sz="1500" dirty="0">
-                <a:solidFill>
-                  <a:srgbClr val="FFFFFF"/>
-                </a:solidFill>
-                <a:latin typeface="Arial" pitchFamily="34" charset="0"/>
-                <a:ea typeface="Arial" pitchFamily="34" charset="-122"/>
-                <a:cs typeface="Arial" pitchFamily="34" charset="-120"/>
-              </a:rPr>
-              <a:t>Memoria, compiladores, sistemas operativos. El código era escaso y caro.</a:t>
-            </a:r>
-            <a:endParaRPr lang="en-US" sz="1500" dirty="0"/>
-          </a:p>
-        </p:txBody>
-      </p:sp>
-      <p:sp>
-        <p:nvSpPr>
-          <p:cNvPr id="11" name="Shape 7"/>
-          <p:cNvSpPr/>
-          <p:nvPr/>
-        </p:nvSpPr>
-        <p:spPr>
+            <a:ln w="12700">
+              <a:solidFill>
+                <a:srgbClr val="2C3852"/>
+              </a:solidFill>
+              <a:prstDash val="solid"/>
+            </a:ln>
+          </p:spPr>
+          <p:txBody>
+            <a:bodyPr/>
+            <a:lstStyle/>
+            <a:p>
+              <a:endParaRPr lang="en-CO"/>
+            </a:p>
+          </p:txBody>
+        </p:sp>
+        <p:sp>
+          <p:nvSpPr>
+            <p:cNvPr id="9" name="Text 5"/>
+            <p:cNvSpPr/>
+            <p:nvPr/>
+          </p:nvSpPr>
+          <p:spPr>
+            <a:xfrm>
+              <a:off x="1143000" y="2423160"/>
+              <a:ext cx="1756334" cy="320040"/>
+            </a:xfrm>
+            <a:prstGeom prst="rect">
+              <a:avLst/>
+            </a:prstGeom>
+            <a:noFill/>
+            <a:ln/>
+          </p:spPr>
+          <p:txBody>
+            <a:bodyPr wrap="square" lIns="0" tIns="0" rIns="0" bIns="0" rtlCol="0" anchor="ctr"/>
+            <a:lstStyle/>
+            <a:p>
+              <a:pPr marL="0" indent="0">
+                <a:buNone/>
+              </a:pPr>
+              <a:r>
+                <a:rPr lang="en-US" sz="1200" b="1" kern="0" spc="200" dirty="0">
+                  <a:solidFill>
+                    <a:srgbClr val="9257F1"/>
+                  </a:solidFill>
+                  <a:latin typeface="Arial" pitchFamily="34" charset="0"/>
+                  <a:ea typeface="Arial" pitchFamily="34" charset="-122"/>
+                  <a:cs typeface="Arial" pitchFamily="34" charset="-120"/>
+                </a:rPr>
+                <a:t>1</a:t>
+              </a:r>
+              <a:endParaRPr lang="en-US" sz="1200" dirty="0"/>
+            </a:p>
+          </p:txBody>
+        </p:sp>
+        <p:sp>
+          <p:nvSpPr>
+            <p:cNvPr id="10" name="Text 6"/>
+            <p:cNvSpPr/>
+            <p:nvPr/>
+          </p:nvSpPr>
+          <p:spPr>
+            <a:xfrm>
+              <a:off x="1143000" y="2880360"/>
+              <a:ext cx="1756334" cy="837530"/>
+            </a:xfrm>
+            <a:prstGeom prst="rect">
+              <a:avLst/>
+            </a:prstGeom>
+            <a:noFill/>
+            <a:ln/>
+          </p:spPr>
+          <p:txBody>
+            <a:bodyPr wrap="square" lIns="0" tIns="0" rIns="0" bIns="0" rtlCol="0" anchor="t"/>
+            <a:lstStyle/>
+            <a:p>
+              <a:pPr marL="0" indent="0">
+                <a:lnSpc>
+                  <a:spcPts val="2600"/>
+                </a:lnSpc>
+                <a:buNone/>
+              </a:pPr>
+              <a:r>
+                <a:rPr lang="en-US" sz="1500" dirty="0">
+                  <a:solidFill>
+                    <a:srgbClr val="B34FFF"/>
+                  </a:solidFill>
+                  <a:latin typeface="Arial" pitchFamily="34" charset="0"/>
+                  <a:ea typeface="Arial" pitchFamily="34" charset="-122"/>
+                  <a:cs typeface="Arial" pitchFamily="34" charset="-120"/>
+                </a:rPr>
+                <a:t>Hablar con la máquina</a:t>
+              </a:r>
+              <a:endParaRPr lang="en-US" sz="1500" dirty="0">
+                <a:solidFill>
+                  <a:srgbClr val="B34FFF"/>
+                </a:solidFill>
+              </a:endParaRPr>
+            </a:p>
+            <a:p>
+              <a:pPr marL="0" indent="0">
+                <a:lnSpc>
+                  <a:spcPts val="2600"/>
+                </a:lnSpc>
+                <a:buNone/>
+              </a:pPr>
+              <a:endParaRPr lang="en-US" sz="1500" dirty="0"/>
+            </a:p>
+            <a:p>
+              <a:pPr marL="0" indent="0">
+                <a:lnSpc>
+                  <a:spcPts val="2600"/>
+                </a:lnSpc>
+                <a:buNone/>
+              </a:pPr>
+              <a:r>
+                <a:rPr lang="en-US" sz="1500" dirty="0">
+                  <a:solidFill>
+                    <a:srgbClr val="FFFFFF"/>
+                  </a:solidFill>
+                  <a:latin typeface="Arial" pitchFamily="34" charset="0"/>
+                  <a:ea typeface="Arial" pitchFamily="34" charset="-122"/>
+                  <a:cs typeface="Arial" pitchFamily="34" charset="-120"/>
+                </a:rPr>
+                <a:t>Memoria, compiladores, sistemas operativos. El código era escaso y caro.</a:t>
+              </a:r>
+              <a:endParaRPr lang="en-US" sz="1500" dirty="0"/>
+            </a:p>
+          </p:txBody>
+        </p:sp>
+      </p:grpSp>
+      <p:grpSp>
+        <p:nvGrpSpPr>
+          <p:cNvPr id="21" name="Group 20">
+            <a:extLst>
+              <a:ext uri="{FF2B5EF4-FFF2-40B4-BE49-F238E27FC236}">
+                <a16:creationId xmlns:a16="http://schemas.microsoft.com/office/drawing/2014/main" id="{8F5F7A03-D588-E76E-7490-60AD668006F6}"/>
+              </a:ext>
+            </a:extLst>
+          </p:cNvPr>
+          <p:cNvGrpSpPr/>
+          <p:nvPr/>
+        </p:nvGrpSpPr>
+        <p:grpSpPr>
           <a:xfrm>
             <a:off x="3539414" y="2103120"/>
             <a:ext cx="2396414" cy="3529584"/>
-          </a:xfrm>
-          <a:prstGeom prst="rect">
-            <a:avLst/>
-          </a:prstGeom>
-          <a:solidFill>
-            <a:srgbClr val="1E2739"/>
-          </a:solidFill>
-          <a:ln w="12700">
+            <a:chOff x="3539414" y="2103120"/>
+            <a:chExt cx="2396414" cy="3529584"/>
+          </a:xfrm>
+        </p:grpSpPr>
+        <p:sp>
+          <p:nvSpPr>
+            <p:cNvPr id="11" name="Shape 7"/>
+            <p:cNvSpPr/>
+            <p:nvPr/>
+          </p:nvSpPr>
+          <p:spPr>
+            <a:xfrm>
+              <a:off x="3539414" y="2103120"/>
+              <a:ext cx="2396414" cy="3529584"/>
+            </a:xfrm>
+            <a:prstGeom prst="rect">
+              <a:avLst/>
+            </a:prstGeom>
             <a:solidFill>
-              <a:srgbClr val="2C3852"/>
+              <a:srgbClr val="1E2739"/>
             </a:solidFill>
-            <a:prstDash val="solid"/>
-          </a:ln>
-        </p:spPr>
-        <p:txBody>
-          <a:bodyPr/>
-          <a:lstStyle/>
-          <a:p>
-            <a:endParaRPr lang="en-CO"/>
-          </a:p>
-        </p:txBody>
-      </p:sp>
-      <p:sp>
-        <p:nvSpPr>
-          <p:cNvPr id="12" name="Text 8"/>
-          <p:cNvSpPr/>
-          <p:nvPr/>
-        </p:nvSpPr>
-        <p:spPr>
-          <a:xfrm>
-            <a:off x="3859454" y="2423160"/>
-            <a:ext cx="1756334" cy="320040"/>
-          </a:xfrm>
-          <a:prstGeom prst="rect">
-            <a:avLst/>
-          </a:prstGeom>
-          <a:noFill/>
-          <a:ln/>
-        </p:spPr>
-        <p:txBody>
-          <a:bodyPr wrap="square" lIns="0" tIns="0" rIns="0" bIns="0" rtlCol="0" anchor="ctr"/>
-          <a:lstStyle/>
-          <a:p>
-            <a:pPr marL="0" indent="0">
-              <a:buNone/>
-            </a:pPr>
-            <a:r>
-              <a:rPr lang="en-US" sz="1200" b="1" kern="0" spc="200" dirty="0">
-                <a:solidFill>
-                  <a:srgbClr val="9257F1"/>
-                </a:solidFill>
-                <a:latin typeface="Arial" pitchFamily="34" charset="0"/>
-                <a:ea typeface="Arial" pitchFamily="34" charset="-122"/>
-                <a:cs typeface="Arial" pitchFamily="34" charset="-120"/>
-              </a:rPr>
-              <a:t>2</a:t>
-            </a:r>
-            <a:endParaRPr lang="en-US" sz="1200" dirty="0"/>
-          </a:p>
-        </p:txBody>
-      </p:sp>
-      <p:sp>
-        <p:nvSpPr>
-          <p:cNvPr id="13" name="Text 9"/>
-          <p:cNvSpPr/>
-          <p:nvPr/>
-        </p:nvSpPr>
-        <p:spPr>
-          <a:xfrm>
-            <a:off x="3859454" y="2880360"/>
-            <a:ext cx="1756334" cy="2148840"/>
-          </a:xfrm>
-          <a:prstGeom prst="rect">
-            <a:avLst/>
-          </a:prstGeom>
-          <a:noFill/>
-          <a:ln/>
-        </p:spPr>
-        <p:txBody>
-          <a:bodyPr wrap="square" lIns="0" tIns="0" rIns="0" bIns="0" rtlCol="0" anchor="t"/>
-          <a:lstStyle/>
-          <a:p>
-            <a:pPr marL="0" indent="0">
-              <a:lnSpc>
-                <a:spcPts val="2600"/>
-              </a:lnSpc>
-              <a:buNone/>
-            </a:pPr>
-            <a:r>
-              <a:rPr lang="en-US" sz="1500" dirty="0">
-                <a:solidFill>
-                  <a:srgbClr val="FFFFFF"/>
-                </a:solidFill>
-                <a:latin typeface="Arial" pitchFamily="34" charset="0"/>
-                <a:ea typeface="Arial" pitchFamily="34" charset="-122"/>
-                <a:cs typeface="Arial" pitchFamily="34" charset="-120"/>
-              </a:rPr>
-              <a:t>Las abstracciones</a:t>
-            </a:r>
-            <a:endParaRPr lang="en-US" sz="1500" dirty="0"/>
-          </a:p>
-          <a:p>
-            <a:pPr marL="0" indent="0">
-              <a:lnSpc>
-                <a:spcPts val="2600"/>
-              </a:lnSpc>
-              <a:buNone/>
-            </a:pPr>
-            <a:endParaRPr lang="en-US" sz="1500" dirty="0"/>
-          </a:p>
-          <a:p>
-            <a:pPr marL="0" indent="0">
-              <a:lnSpc>
-                <a:spcPts val="2600"/>
-              </a:lnSpc>
-              <a:buNone/>
-            </a:pPr>
-            <a:r>
-              <a:rPr lang="en-US" sz="1500" dirty="0">
-                <a:solidFill>
-                  <a:srgbClr val="FFFFFF"/>
-                </a:solidFill>
-                <a:latin typeface="Arial" pitchFamily="34" charset="0"/>
-                <a:ea typeface="Arial" pitchFamily="34" charset="-122"/>
-                <a:cs typeface="Arial" pitchFamily="34" charset="-120"/>
-              </a:rPr>
-              <a:t>Frameworks, cloud, contenedores, IaC, CI/CD. Más con menos esfuerzo.</a:t>
-            </a:r>
-            <a:endParaRPr lang="en-US" sz="1500" dirty="0"/>
-          </a:p>
-        </p:txBody>
-      </p:sp>
-      <p:sp>
-        <p:nvSpPr>
-          <p:cNvPr id="14" name="Shape 10"/>
-          <p:cNvSpPr/>
-          <p:nvPr/>
-        </p:nvSpPr>
-        <p:spPr>
+            <a:ln w="12700">
+              <a:solidFill>
+                <a:srgbClr val="2C3852"/>
+              </a:solidFill>
+              <a:prstDash val="solid"/>
+            </a:ln>
+          </p:spPr>
+          <p:txBody>
+            <a:bodyPr/>
+            <a:lstStyle/>
+            <a:p>
+              <a:endParaRPr lang="en-CO"/>
+            </a:p>
+          </p:txBody>
+        </p:sp>
+        <p:sp>
+          <p:nvSpPr>
+            <p:cNvPr id="12" name="Text 8"/>
+            <p:cNvSpPr/>
+            <p:nvPr/>
+          </p:nvSpPr>
+          <p:spPr>
+            <a:xfrm>
+              <a:off x="3859454" y="2423160"/>
+              <a:ext cx="1756334" cy="320040"/>
+            </a:xfrm>
+            <a:prstGeom prst="rect">
+              <a:avLst/>
+            </a:prstGeom>
+            <a:noFill/>
+            <a:ln/>
+          </p:spPr>
+          <p:txBody>
+            <a:bodyPr wrap="square" lIns="0" tIns="0" rIns="0" bIns="0" rtlCol="0" anchor="ctr"/>
+            <a:lstStyle/>
+            <a:p>
+              <a:pPr marL="0" indent="0">
+                <a:buNone/>
+              </a:pPr>
+              <a:r>
+                <a:rPr lang="en-US" sz="1200" b="1" kern="0" spc="200" dirty="0">
+                  <a:solidFill>
+                    <a:srgbClr val="9257F1"/>
+                  </a:solidFill>
+                  <a:latin typeface="Arial" pitchFamily="34" charset="0"/>
+                  <a:ea typeface="Arial" pitchFamily="34" charset="-122"/>
+                  <a:cs typeface="Arial" pitchFamily="34" charset="-120"/>
+                </a:rPr>
+                <a:t>2</a:t>
+              </a:r>
+              <a:endParaRPr lang="en-US" sz="1200" dirty="0"/>
+            </a:p>
+          </p:txBody>
+        </p:sp>
+        <p:sp>
+          <p:nvSpPr>
+            <p:cNvPr id="13" name="Text 9"/>
+            <p:cNvSpPr/>
+            <p:nvPr/>
+          </p:nvSpPr>
+          <p:spPr>
+            <a:xfrm>
+              <a:off x="3859454" y="2880360"/>
+              <a:ext cx="1756334" cy="2148840"/>
+            </a:xfrm>
+            <a:prstGeom prst="rect">
+              <a:avLst/>
+            </a:prstGeom>
+            <a:noFill/>
+            <a:ln/>
+          </p:spPr>
+          <p:txBody>
+            <a:bodyPr wrap="square" lIns="0" tIns="0" rIns="0" bIns="0" rtlCol="0" anchor="t"/>
+            <a:lstStyle/>
+            <a:p>
+              <a:pPr marL="0" indent="0">
+                <a:lnSpc>
+                  <a:spcPts val="2600"/>
+                </a:lnSpc>
+                <a:buNone/>
+              </a:pPr>
+              <a:r>
+                <a:rPr lang="en-US" sz="1500" dirty="0">
+                  <a:solidFill>
+                    <a:srgbClr val="B34FFF"/>
+                  </a:solidFill>
+                  <a:latin typeface="Arial" pitchFamily="34" charset="0"/>
+                  <a:ea typeface="Arial" pitchFamily="34" charset="-122"/>
+                  <a:cs typeface="Arial" pitchFamily="34" charset="-120"/>
+                </a:rPr>
+                <a:t>Las abstracciones</a:t>
+              </a:r>
+              <a:endParaRPr lang="en-US" sz="1500" dirty="0">
+                <a:solidFill>
+                  <a:srgbClr val="B34FFF"/>
+                </a:solidFill>
+              </a:endParaRPr>
+            </a:p>
+            <a:p>
+              <a:pPr marL="0" indent="0">
+                <a:lnSpc>
+                  <a:spcPts val="2600"/>
+                </a:lnSpc>
+                <a:buNone/>
+              </a:pPr>
+              <a:endParaRPr lang="en-US" sz="1500" dirty="0"/>
+            </a:p>
+            <a:p>
+              <a:pPr marL="0" indent="0">
+                <a:lnSpc>
+                  <a:spcPts val="2600"/>
+                </a:lnSpc>
+                <a:buNone/>
+              </a:pPr>
+              <a:r>
+                <a:rPr lang="en-US" sz="1500" dirty="0">
+                  <a:solidFill>
+                    <a:srgbClr val="FFFFFF"/>
+                  </a:solidFill>
+                  <a:latin typeface="Arial" pitchFamily="34" charset="0"/>
+                  <a:ea typeface="Arial" pitchFamily="34" charset="-122"/>
+                  <a:cs typeface="Arial" pitchFamily="34" charset="-120"/>
+                </a:rPr>
+                <a:t>Frameworks, cloud, contenedores, IaC, CI/CD. Más con menos esfuerzo.</a:t>
+              </a:r>
+              <a:endParaRPr lang="en-US" sz="1500" dirty="0"/>
+            </a:p>
+          </p:txBody>
+        </p:sp>
+      </p:grpSp>
+      <p:grpSp>
+        <p:nvGrpSpPr>
+          <p:cNvPr id="22" name="Group 21">
+            <a:extLst>
+              <a:ext uri="{FF2B5EF4-FFF2-40B4-BE49-F238E27FC236}">
+                <a16:creationId xmlns:a16="http://schemas.microsoft.com/office/drawing/2014/main" id="{191875B1-3AC6-A2D1-BC95-ED0E64994F94}"/>
+              </a:ext>
+            </a:extLst>
+          </p:cNvPr>
+          <p:cNvGrpSpPr/>
+          <p:nvPr/>
+        </p:nvGrpSpPr>
+        <p:grpSpPr>
           <a:xfrm>
             <a:off x="6255868" y="2103120"/>
             <a:ext cx="2396414" cy="3529584"/>
-          </a:xfrm>
-          <a:prstGeom prst="rect">
-            <a:avLst/>
-          </a:prstGeom>
-          <a:solidFill>
-            <a:srgbClr val="1E2739"/>
-          </a:solidFill>
-          <a:ln w="12700">
+            <a:chOff x="6255868" y="2103120"/>
+            <a:chExt cx="2396414" cy="3529584"/>
+          </a:xfrm>
+        </p:grpSpPr>
+        <p:sp>
+          <p:nvSpPr>
+            <p:cNvPr id="14" name="Shape 10"/>
+            <p:cNvSpPr/>
+            <p:nvPr/>
+          </p:nvSpPr>
+          <p:spPr>
+            <a:xfrm>
+              <a:off x="6255868" y="2103120"/>
+              <a:ext cx="2396414" cy="3529584"/>
+            </a:xfrm>
+            <a:prstGeom prst="rect">
+              <a:avLst/>
+            </a:prstGeom>
             <a:solidFill>
-              <a:srgbClr val="2C3852"/>
+              <a:srgbClr val="1E2739"/>
             </a:solidFill>
-            <a:prstDash val="solid"/>
-          </a:ln>
-        </p:spPr>
-        <p:txBody>
-          <a:bodyPr/>
-          <a:lstStyle/>
-          <a:p>
-            <a:endParaRPr lang="en-CO"/>
-          </a:p>
-        </p:txBody>
-      </p:sp>
-      <p:sp>
-        <p:nvSpPr>
-          <p:cNvPr id="15" name="Text 11"/>
-          <p:cNvSpPr/>
-          <p:nvPr/>
-        </p:nvSpPr>
-        <p:spPr>
-          <a:xfrm>
-            <a:off x="6575908" y="2423160"/>
-            <a:ext cx="1756334" cy="320040"/>
-          </a:xfrm>
-          <a:prstGeom prst="rect">
-            <a:avLst/>
-          </a:prstGeom>
-          <a:noFill/>
-          <a:ln/>
-        </p:spPr>
-        <p:txBody>
-          <a:bodyPr wrap="square" lIns="0" tIns="0" rIns="0" bIns="0" rtlCol="0" anchor="ctr"/>
-          <a:lstStyle/>
-          <a:p>
-            <a:pPr marL="0" indent="0">
-              <a:buNone/>
-            </a:pPr>
-            <a:r>
-              <a:rPr lang="en-US" sz="1200" b="1" kern="0" spc="200" dirty="0">
-                <a:solidFill>
-                  <a:srgbClr val="9257F1"/>
-                </a:solidFill>
-                <a:latin typeface="Arial" pitchFamily="34" charset="0"/>
-                <a:ea typeface="Arial" pitchFamily="34" charset="-122"/>
-                <a:cs typeface="Arial" pitchFamily="34" charset="-120"/>
-              </a:rPr>
-              <a:t>3</a:t>
-            </a:r>
-            <a:endParaRPr lang="en-US" sz="1200" dirty="0"/>
-          </a:p>
-        </p:txBody>
-      </p:sp>
-      <p:sp>
-        <p:nvSpPr>
-          <p:cNvPr id="16" name="Text 12"/>
-          <p:cNvSpPr/>
-          <p:nvPr/>
-        </p:nvSpPr>
-        <p:spPr>
-          <a:xfrm>
-            <a:off x="6575908" y="2880360"/>
-            <a:ext cx="1756334" cy="2148840"/>
-          </a:xfrm>
-          <a:prstGeom prst="rect">
-            <a:avLst/>
-          </a:prstGeom>
-          <a:noFill/>
-          <a:ln/>
-        </p:spPr>
-        <p:txBody>
-          <a:bodyPr wrap="square" lIns="0" tIns="0" rIns="0" bIns="0" rtlCol="0" anchor="t"/>
-          <a:lstStyle/>
-          <a:p>
-            <a:pPr marL="0" indent="0">
-              <a:lnSpc>
-                <a:spcPts val="2600"/>
-              </a:lnSpc>
-              <a:buNone/>
-            </a:pPr>
-            <a:r>
-              <a:rPr lang="en-US" sz="1500" dirty="0">
-                <a:solidFill>
-                  <a:srgbClr val="FFFFFF"/>
-                </a:solidFill>
-                <a:latin typeface="Arial" pitchFamily="34" charset="0"/>
-                <a:ea typeface="Arial" pitchFamily="34" charset="-122"/>
-                <a:cs typeface="Arial" pitchFamily="34" charset="-120"/>
-              </a:rPr>
-              <a:t>Google y Stack Overflow</a:t>
-            </a:r>
-            <a:endParaRPr lang="en-US" sz="1500" dirty="0"/>
-          </a:p>
-          <a:p>
-            <a:pPr marL="0" indent="0">
-              <a:lnSpc>
-                <a:spcPts val="2600"/>
-              </a:lnSpc>
-              <a:buNone/>
-            </a:pPr>
-            <a:endParaRPr lang="en-US" sz="1500" dirty="0"/>
-          </a:p>
-          <a:p>
-            <a:pPr marL="0" indent="0">
-              <a:lnSpc>
-                <a:spcPts val="2600"/>
-              </a:lnSpc>
-              <a:buNone/>
-            </a:pPr>
-            <a:r>
-              <a:rPr lang="en-US" sz="1500" dirty="0">
-                <a:solidFill>
-                  <a:srgbClr val="FFFFFF"/>
-                </a:solidFill>
-                <a:latin typeface="Arial" pitchFamily="34" charset="0"/>
-                <a:ea typeface="Arial" pitchFamily="34" charset="-122"/>
-                <a:cs typeface="Arial" pitchFamily="34" charset="-120"/>
-              </a:rPr>
-              <a:t>Dejamos de memorizar. La habilidad pasó a ser encontrar la respuesta.</a:t>
-            </a:r>
-            <a:endParaRPr lang="en-US" sz="1500" dirty="0"/>
-          </a:p>
-        </p:txBody>
-      </p:sp>
-      <p:sp>
-        <p:nvSpPr>
-          <p:cNvPr id="17" name="Shape 13"/>
-          <p:cNvSpPr/>
-          <p:nvPr/>
-        </p:nvSpPr>
-        <p:spPr>
+            <a:ln w="12700">
+              <a:solidFill>
+                <a:srgbClr val="2C3852"/>
+              </a:solidFill>
+              <a:prstDash val="solid"/>
+            </a:ln>
+          </p:spPr>
+          <p:txBody>
+            <a:bodyPr/>
+            <a:lstStyle/>
+            <a:p>
+              <a:endParaRPr lang="en-CO"/>
+            </a:p>
+          </p:txBody>
+        </p:sp>
+        <p:sp>
+          <p:nvSpPr>
+            <p:cNvPr id="15" name="Text 11"/>
+            <p:cNvSpPr/>
+            <p:nvPr/>
+          </p:nvSpPr>
+          <p:spPr>
+            <a:xfrm>
+              <a:off x="6575908" y="2423160"/>
+              <a:ext cx="1756334" cy="320040"/>
+            </a:xfrm>
+            <a:prstGeom prst="rect">
+              <a:avLst/>
+            </a:prstGeom>
+            <a:noFill/>
+            <a:ln/>
+          </p:spPr>
+          <p:txBody>
+            <a:bodyPr wrap="square" lIns="0" tIns="0" rIns="0" bIns="0" rtlCol="0" anchor="ctr"/>
+            <a:lstStyle/>
+            <a:p>
+              <a:pPr marL="0" indent="0">
+                <a:buNone/>
+              </a:pPr>
+              <a:r>
+                <a:rPr lang="en-US" sz="1200" b="1" kern="0" spc="200" dirty="0">
+                  <a:solidFill>
+                    <a:srgbClr val="9257F1"/>
+                  </a:solidFill>
+                  <a:latin typeface="Arial" pitchFamily="34" charset="0"/>
+                  <a:ea typeface="Arial" pitchFamily="34" charset="-122"/>
+                  <a:cs typeface="Arial" pitchFamily="34" charset="-120"/>
+                </a:rPr>
+                <a:t>3</a:t>
+              </a:r>
+              <a:endParaRPr lang="en-US" sz="1200" dirty="0"/>
+            </a:p>
+          </p:txBody>
+        </p:sp>
+        <p:sp>
+          <p:nvSpPr>
+            <p:cNvPr id="16" name="Text 12"/>
+            <p:cNvSpPr/>
+            <p:nvPr/>
+          </p:nvSpPr>
+          <p:spPr>
+            <a:xfrm>
+              <a:off x="6575908" y="2880360"/>
+              <a:ext cx="1756334" cy="2148840"/>
+            </a:xfrm>
+            <a:prstGeom prst="rect">
+              <a:avLst/>
+            </a:prstGeom>
+            <a:noFill/>
+            <a:ln/>
+          </p:spPr>
+          <p:txBody>
+            <a:bodyPr wrap="square" lIns="0" tIns="0" rIns="0" bIns="0" rtlCol="0" anchor="t"/>
+            <a:lstStyle/>
+            <a:p>
+              <a:pPr marL="0" indent="0">
+                <a:lnSpc>
+                  <a:spcPts val="2600"/>
+                </a:lnSpc>
+                <a:buNone/>
+              </a:pPr>
+              <a:r>
+                <a:rPr lang="en-US" sz="1500" dirty="0">
+                  <a:solidFill>
+                    <a:srgbClr val="B34FFF"/>
+                  </a:solidFill>
+                  <a:latin typeface="Arial" pitchFamily="34" charset="0"/>
+                  <a:ea typeface="Arial" pitchFamily="34" charset="-122"/>
+                  <a:cs typeface="Arial" pitchFamily="34" charset="-120"/>
+                </a:rPr>
+                <a:t>Google y Stack Overflow</a:t>
+              </a:r>
+              <a:endParaRPr lang="en-US" sz="1500" dirty="0">
+                <a:solidFill>
+                  <a:srgbClr val="B34FFF"/>
+                </a:solidFill>
+              </a:endParaRPr>
+            </a:p>
+            <a:p>
+              <a:pPr marL="0" indent="0">
+                <a:lnSpc>
+                  <a:spcPts val="2600"/>
+                </a:lnSpc>
+                <a:buNone/>
+              </a:pPr>
+              <a:endParaRPr lang="en-US" sz="1500" dirty="0"/>
+            </a:p>
+            <a:p>
+              <a:pPr marL="0" indent="0">
+                <a:lnSpc>
+                  <a:spcPts val="2600"/>
+                </a:lnSpc>
+                <a:buNone/>
+              </a:pPr>
+              <a:r>
+                <a:rPr lang="en-US" sz="1500" dirty="0">
+                  <a:solidFill>
+                    <a:srgbClr val="FFFFFF"/>
+                  </a:solidFill>
+                  <a:latin typeface="Arial" pitchFamily="34" charset="0"/>
+                  <a:ea typeface="Arial" pitchFamily="34" charset="-122"/>
+                  <a:cs typeface="Arial" pitchFamily="34" charset="-120"/>
+                </a:rPr>
+                <a:t>Dejamos de memorizar. La habilidad pasó a ser encontrar la respuesta.</a:t>
+              </a:r>
+              <a:endParaRPr lang="en-US" sz="1500" dirty="0"/>
+            </a:p>
+          </p:txBody>
+        </p:sp>
+      </p:grpSp>
+      <p:grpSp>
+        <p:nvGrpSpPr>
+          <p:cNvPr id="23" name="Group 22">
+            <a:extLst>
+              <a:ext uri="{FF2B5EF4-FFF2-40B4-BE49-F238E27FC236}">
+                <a16:creationId xmlns:a16="http://schemas.microsoft.com/office/drawing/2014/main" id="{BE8C0F0D-461E-9493-8491-7AA0BC2448C0}"/>
+              </a:ext>
+            </a:extLst>
+          </p:cNvPr>
+          <p:cNvGrpSpPr/>
+          <p:nvPr/>
+        </p:nvGrpSpPr>
+        <p:grpSpPr>
           <a:xfrm>
             <a:off x="8972321" y="2103120"/>
             <a:ext cx="2396414" cy="3529584"/>
-          </a:xfrm>
-          <a:prstGeom prst="rect">
-            <a:avLst/>
-          </a:prstGeom>
-          <a:solidFill>
-            <a:srgbClr val="1E2739"/>
-          </a:solidFill>
-          <a:ln w="12700">
+            <a:chOff x="8972321" y="2103120"/>
+            <a:chExt cx="2396414" cy="3529584"/>
+          </a:xfrm>
+        </p:grpSpPr>
+        <p:sp>
+          <p:nvSpPr>
+            <p:cNvPr id="17" name="Shape 13"/>
+            <p:cNvSpPr/>
+            <p:nvPr/>
+          </p:nvSpPr>
+          <p:spPr>
+            <a:xfrm>
+              <a:off x="8972321" y="2103120"/>
+              <a:ext cx="2396414" cy="3529584"/>
+            </a:xfrm>
+            <a:prstGeom prst="rect">
+              <a:avLst/>
+            </a:prstGeom>
             <a:solidFill>
-              <a:srgbClr val="2C3852"/>
+              <a:srgbClr val="1E2739"/>
             </a:solidFill>
-            <a:prstDash val="solid"/>
-          </a:ln>
-        </p:spPr>
-        <p:txBody>
-          <a:bodyPr/>
-          <a:lstStyle/>
-          <a:p>
-            <a:endParaRPr lang="en-CO"/>
-          </a:p>
-        </p:txBody>
-      </p:sp>
-      <p:sp>
-        <p:nvSpPr>
-          <p:cNvPr id="18" name="Text 14"/>
-          <p:cNvSpPr/>
-          <p:nvPr/>
-        </p:nvSpPr>
-        <p:spPr>
-          <a:xfrm>
-            <a:off x="9292361" y="2423160"/>
-            <a:ext cx="1756334" cy="320040"/>
-          </a:xfrm>
-          <a:prstGeom prst="rect">
-            <a:avLst/>
-          </a:prstGeom>
-          <a:noFill/>
-          <a:ln/>
-        </p:spPr>
-        <p:txBody>
-          <a:bodyPr wrap="square" lIns="0" tIns="0" rIns="0" bIns="0" rtlCol="0" anchor="ctr"/>
-          <a:lstStyle/>
-          <a:p>
-            <a:pPr marL="0" indent="0">
-              <a:buNone/>
-            </a:pPr>
-            <a:r>
-              <a:rPr lang="en-US" sz="1200" b="1" kern="0" spc="200" dirty="0">
-                <a:solidFill>
-                  <a:srgbClr val="9257F1"/>
-                </a:solidFill>
-                <a:latin typeface="Arial" pitchFamily="34" charset="0"/>
-                <a:ea typeface="Arial" pitchFamily="34" charset="-122"/>
-                <a:cs typeface="Arial" pitchFamily="34" charset="-120"/>
-              </a:rPr>
-              <a:t>4</a:t>
-            </a:r>
-            <a:endParaRPr lang="en-US" sz="1200" dirty="0"/>
-          </a:p>
-        </p:txBody>
-      </p:sp>
-      <p:sp>
-        <p:nvSpPr>
-          <p:cNvPr id="19" name="Text 15"/>
-          <p:cNvSpPr/>
-          <p:nvPr/>
-        </p:nvSpPr>
-        <p:spPr>
-          <a:xfrm>
-            <a:off x="9292361" y="2880360"/>
-            <a:ext cx="1756334" cy="2148840"/>
-          </a:xfrm>
-          <a:prstGeom prst="rect">
-            <a:avLst/>
-          </a:prstGeom>
-          <a:noFill/>
-          <a:ln/>
-        </p:spPr>
-        <p:txBody>
-          <a:bodyPr wrap="square" lIns="0" tIns="0" rIns="0" bIns="0" rtlCol="0" anchor="t"/>
-          <a:lstStyle/>
-          <a:p>
-            <a:pPr marL="0" indent="0">
-              <a:lnSpc>
-                <a:spcPts val="2600"/>
-              </a:lnSpc>
-              <a:buNone/>
-            </a:pPr>
-            <a:r>
-              <a:rPr lang="en-US" sz="1500" dirty="0">
-                <a:solidFill>
-                  <a:srgbClr val="FFFFFF"/>
-                </a:solidFill>
-                <a:latin typeface="Arial" pitchFamily="34" charset="0"/>
-                <a:ea typeface="Arial" pitchFamily="34" charset="-122"/>
-                <a:cs typeface="Arial" pitchFamily="34" charset="-120"/>
-              </a:rPr>
-              <a:t>IA generativa</a:t>
-            </a:r>
-            <a:endParaRPr lang="en-US" sz="1500" dirty="0"/>
-          </a:p>
-          <a:p>
-            <a:pPr marL="0" indent="0">
-              <a:lnSpc>
-                <a:spcPts val="2600"/>
-              </a:lnSpc>
-              <a:buNone/>
-            </a:pPr>
-            <a:endParaRPr lang="en-US" sz="1500" dirty="0"/>
-          </a:p>
-          <a:p>
-            <a:pPr marL="0" indent="0">
-              <a:lnSpc>
-                <a:spcPts val="2600"/>
-              </a:lnSpc>
-              <a:buNone/>
-            </a:pPr>
-            <a:r>
-              <a:rPr lang="en-US" sz="1500" dirty="0">
-                <a:solidFill>
-                  <a:srgbClr val="FFFFFF"/>
-                </a:solidFill>
-                <a:latin typeface="Arial" pitchFamily="34" charset="0"/>
-                <a:ea typeface="Arial" pitchFamily="34" charset="-122"/>
-                <a:cs typeface="Arial" pitchFamily="34" charset="-120"/>
-              </a:rPr>
-              <a:t>Ya no buscamos la respuesta. Automatizamos la producción del código.</a:t>
-            </a:r>
-            <a:endParaRPr lang="en-US" sz="1500" dirty="0"/>
-          </a:p>
-        </p:txBody>
-      </p:sp>
+            <a:ln w="12700">
+              <a:solidFill>
+                <a:srgbClr val="2C3852"/>
+              </a:solidFill>
+              <a:prstDash val="solid"/>
+            </a:ln>
+          </p:spPr>
+          <p:txBody>
+            <a:bodyPr/>
+            <a:lstStyle/>
+            <a:p>
+              <a:endParaRPr lang="en-CO"/>
+            </a:p>
+          </p:txBody>
+        </p:sp>
+        <p:sp>
+          <p:nvSpPr>
+            <p:cNvPr id="18" name="Text 14"/>
+            <p:cNvSpPr/>
+            <p:nvPr/>
+          </p:nvSpPr>
+          <p:spPr>
+            <a:xfrm>
+              <a:off x="9292361" y="2423160"/>
+              <a:ext cx="1756334" cy="320040"/>
+            </a:xfrm>
+            <a:prstGeom prst="rect">
+              <a:avLst/>
+            </a:prstGeom>
+            <a:noFill/>
+            <a:ln/>
+          </p:spPr>
+          <p:txBody>
+            <a:bodyPr wrap="square" lIns="0" tIns="0" rIns="0" bIns="0" rtlCol="0" anchor="ctr"/>
+            <a:lstStyle/>
+            <a:p>
+              <a:pPr marL="0" indent="0">
+                <a:buNone/>
+              </a:pPr>
+              <a:r>
+                <a:rPr lang="en-US" sz="1200" b="1" kern="0" spc="200" dirty="0">
+                  <a:solidFill>
+                    <a:srgbClr val="9257F1"/>
+                  </a:solidFill>
+                  <a:latin typeface="Arial" pitchFamily="34" charset="0"/>
+                  <a:ea typeface="Arial" pitchFamily="34" charset="-122"/>
+                  <a:cs typeface="Arial" pitchFamily="34" charset="-120"/>
+                </a:rPr>
+                <a:t>4</a:t>
+              </a:r>
+              <a:endParaRPr lang="en-US" sz="1200" dirty="0"/>
+            </a:p>
+          </p:txBody>
+        </p:sp>
+        <p:sp>
+          <p:nvSpPr>
+            <p:cNvPr id="19" name="Text 15"/>
+            <p:cNvSpPr/>
+            <p:nvPr/>
+          </p:nvSpPr>
+          <p:spPr>
+            <a:xfrm>
+              <a:off x="9292361" y="2880360"/>
+              <a:ext cx="1756334" cy="2148840"/>
+            </a:xfrm>
+            <a:prstGeom prst="rect">
+              <a:avLst/>
+            </a:prstGeom>
+            <a:noFill/>
+            <a:ln/>
+          </p:spPr>
+          <p:txBody>
+            <a:bodyPr wrap="square" lIns="0" tIns="0" rIns="0" bIns="0" rtlCol="0" anchor="t"/>
+            <a:lstStyle/>
+            <a:p>
+              <a:pPr marL="0" indent="0">
+                <a:lnSpc>
+                  <a:spcPts val="2600"/>
+                </a:lnSpc>
+                <a:buNone/>
+              </a:pPr>
+              <a:r>
+                <a:rPr lang="en-US" sz="1500" dirty="0">
+                  <a:solidFill>
+                    <a:srgbClr val="B34FFF"/>
+                  </a:solidFill>
+                  <a:latin typeface="Arial" pitchFamily="34" charset="0"/>
+                  <a:ea typeface="Arial" pitchFamily="34" charset="-122"/>
+                  <a:cs typeface="Arial" pitchFamily="34" charset="-120"/>
+                </a:rPr>
+                <a:t>IA generativa</a:t>
+              </a:r>
+              <a:endParaRPr lang="en-US" sz="1500" dirty="0">
+                <a:solidFill>
+                  <a:srgbClr val="B34FFF"/>
+                </a:solidFill>
+              </a:endParaRPr>
+            </a:p>
+            <a:p>
+              <a:pPr marL="0" indent="0">
+                <a:lnSpc>
+                  <a:spcPts val="2600"/>
+                </a:lnSpc>
+                <a:buNone/>
+              </a:pPr>
+              <a:endParaRPr lang="en-US" sz="1500" dirty="0"/>
+            </a:p>
+            <a:p>
+              <a:pPr marL="0" indent="0">
+                <a:lnSpc>
+                  <a:spcPts val="2600"/>
+                </a:lnSpc>
+                <a:buNone/>
+              </a:pPr>
+              <a:r>
+                <a:rPr lang="en-US" sz="1500" dirty="0">
+                  <a:solidFill>
+                    <a:srgbClr val="FFFFFF"/>
+                  </a:solidFill>
+                  <a:latin typeface="Arial" pitchFamily="34" charset="0"/>
+                  <a:ea typeface="Arial" pitchFamily="34" charset="-122"/>
+                  <a:cs typeface="Arial" pitchFamily="34" charset="-120"/>
+                </a:rPr>
+                <a:t>Ya no buscamos la respuesta. Automatizamos la producción del código.</a:t>
+              </a:r>
+              <a:endParaRPr lang="en-US" sz="1500" dirty="0"/>
+            </a:p>
+          </p:txBody>
+        </p:sp>
+      </p:grpSp>
       <p:sp>
         <p:nvSpPr>
           <p:cNvPr id="20" name="Text 16"/>
@@ -6144,7 +6244,29 @@
                 <a:ea typeface="Arial" pitchFamily="34" charset="-122"/>
                 <a:cs typeface="Arial" pitchFamily="34" charset="-120"/>
               </a:rPr>
-              <a:t>no eliminó a los ingenieros</a:t>
+              <a:t>no eliminó a </a:t>
+            </a:r>
+            <a:r>
+              <a:rPr lang="en-US" sz="2400" dirty="0" err="1">
+                <a:solidFill>
+                  <a:srgbClr val="8A93A8"/>
+                </a:solidFill>
+                <a:latin typeface="Arial" pitchFamily="34" charset="0"/>
+                <a:ea typeface="Arial" pitchFamily="34" charset="-122"/>
+                <a:cs typeface="Arial" pitchFamily="34" charset="-120"/>
+              </a:rPr>
+              <a:t>los</a:t>
+            </a:r>
+            <a:r>
+              <a:rPr lang="en-US" sz="2400" dirty="0">
+                <a:solidFill>
+                  <a:srgbClr val="8A93A8"/>
+                </a:solidFill>
+                <a:latin typeface="Arial" pitchFamily="34" charset="0"/>
+                <a:ea typeface="Arial" pitchFamily="34" charset="-122"/>
+                <a:cs typeface="Arial" pitchFamily="34" charset="-120"/>
+              </a:rPr>
+              <a:t> Ingenieros de infra</a:t>
             </a:r>
             <a:endParaRPr lang="en-US" sz="2400" dirty="0"/>
           </a:p>
@@ -7276,7 +7398,7 @@
               <a:buNone/>
             </a:pPr>
             <a:r>
-              <a:rPr lang="en-US" sz="2600" dirty="0">
+              <a:rPr lang="en-US" sz="2600" strike="sngStrike" dirty="0">
                 <a:solidFill>
                   <a:srgbClr val="48536B"/>
                 </a:solidFill>
@@ -7286,7 +7408,7 @@
               </a:rPr>
               <a:t>Problema  →  desarrollador  →  código</a:t>
             </a:r>
-            <a:endParaRPr lang="en-US" sz="2600" dirty="0"/>
+            <a:endParaRPr lang="en-US" sz="2600" strike="sngStrike" dirty="0"/>
           </a:p>
         </p:txBody>
       </p:sp>
@@ -8266,7 +8388,7 @@
               <a:buNone/>
             </a:pPr>
             <a:r>
-              <a:rPr lang="en-US" sz="2200" dirty="0">
+              <a:rPr lang="en-US" sz="2200" strike="sngStrike" dirty="0">
                 <a:solidFill>
                   <a:srgbClr val="48536B"/>
                 </a:solidFill>
@@ -8276,7 +8398,7 @@
               </a:rPr>
               <a:t>“Escribe esta función.”</a:t>
             </a:r>
-            <a:endParaRPr lang="en-US" sz="2200" dirty="0"/>
+            <a:endParaRPr lang="en-US" sz="2200" strike="sngStrike" dirty="0"/>
           </a:p>
         </p:txBody>
       </p:sp>
@@ -8565,6 +8687,17 @@
               <a:buChar char="•"/>
             </a:pPr>
             <a:r>
+              <a:rPr lang="en-US" sz="1600" dirty="0" err="1">
+                <a:solidFill>
+                  <a:srgbClr val="FFFFFF"/>
+                </a:solidFill>
+                <a:latin typeface="Arial" pitchFamily="34" charset="0"/>
+                <a:ea typeface="Arial" pitchFamily="34" charset="-122"/>
+                <a:cs typeface="Arial" pitchFamily="34" charset="-120"/>
+              </a:rPr>
+              <a:t>Ingeniero</a:t>
+            </a:r>
+            <a:r>
               <a:rPr lang="en-US" sz="1600" dirty="0">
                 <a:solidFill>
                   <a:srgbClr val="FFFFFF"/>
@@ -8573,29 +8706,7 @@
                 <a:ea typeface="Arial" pitchFamily="34" charset="-122"/>
                 <a:cs typeface="Arial" pitchFamily="34" charset="-120"/>
               </a:rPr>
-              <a:t>CEO y </a:t>
-            </a:r>
-            <a:r>
-              <a:rPr lang="en-US" sz="1600" dirty="0" err="1">
-                <a:solidFill>
-                  <a:srgbClr val="FFFFFF"/>
-                </a:solidFill>
-                <a:latin typeface="Arial" pitchFamily="34" charset="0"/>
-                <a:ea typeface="Arial" pitchFamily="34" charset="-122"/>
-                <a:cs typeface="Arial" pitchFamily="34" charset="-120"/>
-              </a:rPr>
-              <a:t>Fundador</a:t>
-            </a:r>
-            <a:r>
-              <a:rPr lang="en-US" sz="1600" dirty="0">
-                <a:solidFill>
-                  <a:srgbClr val="FFFFFF"/>
-                </a:solidFill>
-                <a:latin typeface="Arial" pitchFamily="34" charset="0"/>
-                <a:ea typeface="Arial" pitchFamily="34" charset="-122"/>
-                <a:cs typeface="Arial" pitchFamily="34" charset="-120"/>
-              </a:rPr>
-              <a:t> de GLD Consulting</a:t>
+              <a:t> de sistemas de la UFPS</a:t>
             </a:r>
             <a:endParaRPr lang="en-US" sz="1600" dirty="0"/>
           </a:p>
@@ -8608,6 +8719,17 @@
               <a:buChar char="•"/>
             </a:pPr>
             <a:r>
+              <a:rPr lang="en-US" sz="1600" dirty="0" err="1">
+                <a:solidFill>
+                  <a:srgbClr val="FFFFFF"/>
+                </a:solidFill>
+                <a:latin typeface="Arial" pitchFamily="34" charset="0"/>
+                <a:ea typeface="Arial" pitchFamily="34" charset="-122"/>
+                <a:cs typeface="Arial" pitchFamily="34" charset="-120"/>
+              </a:rPr>
+              <a:t>Máster</a:t>
+            </a:r>
+            <a:r>
               <a:rPr lang="en-US" sz="1600" dirty="0">
                 <a:solidFill>
                   <a:srgbClr val="FFFFFF"/>
@@ -8616,7 +8738,73 @@
                 <a:ea typeface="Arial" pitchFamily="34" charset="-122"/>
                 <a:cs typeface="Arial" pitchFamily="34" charset="-120"/>
               </a:rPr>
-              <a:t>Ingeniero de sistemas de la UFPS</a:t>
+              <a:t> en Inteligencia Artificial en el Instituto Europeo de </a:t>
+            </a:r>
+            <a:r>
+              <a:rPr lang="en-US" sz="1600" dirty="0" err="1">
+                <a:solidFill>
+                  <a:srgbClr val="FFFFFF"/>
+                </a:solidFill>
+                <a:latin typeface="Arial" pitchFamily="34" charset="0"/>
+                <a:ea typeface="Arial" pitchFamily="34" charset="-122"/>
+                <a:cs typeface="Arial" pitchFamily="34" charset="-120"/>
+              </a:rPr>
+              <a:t>Postgrado</a:t>
+            </a:r>
+            <a:r>
+              <a:rPr lang="en-US" sz="1600" dirty="0">
+                <a:solidFill>
+                  <a:srgbClr val="FFFFFF"/>
+                </a:solidFill>
+                <a:latin typeface="Arial" pitchFamily="34" charset="0"/>
+                <a:ea typeface="Arial" pitchFamily="34" charset="-122"/>
+                <a:cs typeface="Arial" pitchFamily="34" charset="-120"/>
+              </a:rPr>
+              <a:t> (</a:t>
+            </a:r>
+            <a:r>
+              <a:rPr lang="en-US" sz="1600" dirty="0" err="1">
+                <a:solidFill>
+                  <a:srgbClr val="FFFFFF"/>
+                </a:solidFill>
+                <a:latin typeface="Arial" pitchFamily="34" charset="0"/>
+                <a:ea typeface="Arial" pitchFamily="34" charset="-122"/>
+                <a:cs typeface="Arial" pitchFamily="34" charset="-120"/>
+              </a:rPr>
+              <a:t>en</a:t>
+            </a:r>
+            <a:r>
+              <a:rPr lang="en-US" sz="1600" dirty="0">
+                <a:solidFill>
+                  <a:srgbClr val="FFFFFF"/>
+                </a:solidFill>
+                <a:latin typeface="Arial" pitchFamily="34" charset="0"/>
+                <a:ea typeface="Arial" pitchFamily="34" charset="-122"/>
+                <a:cs typeface="Arial" pitchFamily="34" charset="-120"/>
+              </a:rPr>
+              <a:t> </a:t>
+            </a:r>
+            <a:r>
+              <a:rPr lang="en-US" sz="1600" dirty="0" err="1">
+                <a:solidFill>
+                  <a:srgbClr val="FFFFFF"/>
+                </a:solidFill>
+                <a:latin typeface="Arial" pitchFamily="34" charset="0"/>
+                <a:ea typeface="Arial" pitchFamily="34" charset="-122"/>
+                <a:cs typeface="Arial" pitchFamily="34" charset="-120"/>
+              </a:rPr>
+              <a:t>curso</a:t>
+            </a:r>
+            <a:r>
+              <a:rPr lang="en-US" sz="1600" dirty="0">
+                <a:solidFill>
+                  <a:srgbClr val="FFFFFF"/>
+                </a:solidFill>
+                <a:latin typeface="Arial" pitchFamily="34" charset="0"/>
+                <a:ea typeface="Arial" pitchFamily="34" charset="-122"/>
+                <a:cs typeface="Arial" pitchFamily="34" charset="-120"/>
+              </a:rPr>
+              <a:t>)</a:t>
             </a:r>
             <a:endParaRPr lang="en-US" sz="1600" dirty="0"/>
           </a:p>
@@ -8629,7 +8817,7 @@
               <a:buChar char="•"/>
             </a:pPr>
             <a:r>
-              <a:rPr lang="en-US" sz="1600" dirty="0" err="1">
+              <a:rPr lang="en-US" sz="1600" dirty="0">
                 <a:solidFill>
                   <a:srgbClr val="FFFFFF"/>
                 </a:solidFill>
@@ -8637,86 +8825,8 @@
                 <a:ea typeface="Arial" pitchFamily="34" charset="-122"/>
                 <a:cs typeface="Arial" pitchFamily="34" charset="-120"/>
               </a:rPr>
-              <a:t>Máster</a:t>
-            </a:r>
-            <a:r>
-              <a:rPr lang="en-US" sz="1600" dirty="0">
-                <a:solidFill>
-                  <a:srgbClr val="FFFFFF"/>
-                </a:solidFill>
-                <a:latin typeface="Arial" pitchFamily="34" charset="0"/>
-                <a:ea typeface="Arial" pitchFamily="34" charset="-122"/>
-                <a:cs typeface="Arial" pitchFamily="34" charset="-120"/>
-              </a:rPr>
-              <a:t> en Inteligencia Artificial en el Instituto Europeo de </a:t>
-            </a:r>
-            <a:r>
-              <a:rPr lang="en-US" sz="1600" dirty="0" err="1">
-                <a:solidFill>
-                  <a:srgbClr val="FFFFFF"/>
-                </a:solidFill>
-                <a:latin typeface="Arial" pitchFamily="34" charset="0"/>
-                <a:ea typeface="Arial" pitchFamily="34" charset="-122"/>
-                <a:cs typeface="Arial" pitchFamily="34" charset="-120"/>
-              </a:rPr>
-              <a:t>Postgrado</a:t>
-            </a:r>
-            <a:r>
-              <a:rPr lang="en-US" sz="1600" dirty="0">
-                <a:solidFill>
-                  <a:srgbClr val="FFFFFF"/>
-                </a:solidFill>
-                <a:latin typeface="Arial" pitchFamily="34" charset="0"/>
-                <a:ea typeface="Arial" pitchFamily="34" charset="-122"/>
-                <a:cs typeface="Arial" pitchFamily="34" charset="-120"/>
-              </a:rPr>
-              <a:t> (</a:t>
-            </a:r>
-            <a:r>
-              <a:rPr lang="en-US" sz="1600" dirty="0" err="1">
-                <a:solidFill>
-                  <a:srgbClr val="FFFFFF"/>
-                </a:solidFill>
-                <a:latin typeface="Arial" pitchFamily="34" charset="0"/>
-                <a:ea typeface="Arial" pitchFamily="34" charset="-122"/>
-                <a:cs typeface="Arial" pitchFamily="34" charset="-120"/>
-              </a:rPr>
-              <a:t>en</a:t>
-            </a:r>
-            <a:r>
-              <a:rPr lang="en-US" sz="1600" dirty="0">
-                <a:solidFill>
-                  <a:srgbClr val="FFFFFF"/>
-                </a:solidFill>
-                <a:latin typeface="Arial" pitchFamily="34" charset="0"/>
-                <a:ea typeface="Arial" pitchFamily="34" charset="-122"/>
-                <a:cs typeface="Arial" pitchFamily="34" charset="-120"/>
-              </a:rPr>
-              <a:t> </a:t>
-            </a:r>
-            <a:r>
-              <a:rPr lang="en-US" sz="1600" dirty="0" err="1">
-                <a:solidFill>
-                  <a:srgbClr val="FFFFFF"/>
-                </a:solidFill>
-                <a:latin typeface="Arial" pitchFamily="34" charset="0"/>
-                <a:ea typeface="Arial" pitchFamily="34" charset="-122"/>
-                <a:cs typeface="Arial" pitchFamily="34" charset="-120"/>
-              </a:rPr>
-              <a:t>curso</a:t>
-            </a:r>
-            <a:r>
-              <a:rPr lang="en-US" sz="1600" dirty="0">
-                <a:solidFill>
-                  <a:srgbClr val="FFFFFF"/>
-                </a:solidFill>
-                <a:latin typeface="Arial" pitchFamily="34" charset="0"/>
-                <a:ea typeface="Arial" pitchFamily="34" charset="-122"/>
-                <a:cs typeface="Arial" pitchFamily="34" charset="-120"/>
-              </a:rPr>
-              <a:t>)</a:t>
-            </a:r>
-            <a:endParaRPr lang="en-US" sz="1600" dirty="0"/>
+              <a:t>17 años de experiencia en IT y Desarrollo de Software</a:t>
+            </a:r>
           </a:p>
           <a:p>
             <a:pPr marL="342900" indent="-342900">
@@ -8724,6 +8834,7 @@
                 <a:spcPts val="900"/>
               </a:spcAft>
               <a:buSzPct val="100000"/>
+              <a:buFontTx/>
               <a:buChar char="•"/>
             </a:pPr>
             <a:r>
@@ -8735,7 +8846,29 @@
                 <a:ea typeface="Arial" pitchFamily="34" charset="-122"/>
                 <a:cs typeface="Arial" pitchFamily="34" charset="-120"/>
               </a:rPr>
-              <a:t>17 años de experiencia en IT y desarrollo de software</a:t>
+              <a:t>CEO y </a:t>
+            </a:r>
+            <a:r>
+              <a:rPr lang="en-US" sz="1600" dirty="0" err="1">
+                <a:solidFill>
+                  <a:srgbClr val="FFFFFF"/>
+                </a:solidFill>
+                <a:latin typeface="Arial" pitchFamily="34" charset="0"/>
+                <a:ea typeface="Arial" pitchFamily="34" charset="-122"/>
+                <a:cs typeface="Arial" pitchFamily="34" charset="-120"/>
+              </a:rPr>
+              <a:t>Fundador</a:t>
+            </a:r>
+            <a:r>
+              <a:rPr lang="en-US" sz="1600" dirty="0">
+                <a:solidFill>
+                  <a:srgbClr val="FFFFFF"/>
+                </a:solidFill>
+                <a:latin typeface="Arial" pitchFamily="34" charset="0"/>
+                <a:ea typeface="Arial" pitchFamily="34" charset="-122"/>
+                <a:cs typeface="Arial" pitchFamily="34" charset="-120"/>
+              </a:rPr>
+              <a:t> de GLD Consulting</a:t>
             </a:r>
             <a:endParaRPr lang="en-US" sz="1600" dirty="0"/>
           </a:p>
@@ -9130,7 +9263,7 @@
               <a:buNone/>
             </a:pPr>
             <a:r>
-              <a:rPr lang="en-US" sz="2800" dirty="0">
+              <a:rPr lang="en-US" sz="2800" strike="sngStrike" dirty="0">
                 <a:solidFill>
                   <a:srgbClr val="48536B"/>
                 </a:solidFill>
@@ -9140,7 +9273,7 @@
               </a:rPr>
               <a:t>“Sé programar en X.”</a:t>
             </a:r>
-            <a:endParaRPr lang="en-US" sz="2800" dirty="0"/>
+            <a:endParaRPr lang="en-US" sz="2800" strike="sngStrike" dirty="0"/>
           </a:p>
         </p:txBody>
       </p:sp>
@@ -11059,6 +11192,268 @@
   <p:clrMapOvr>
     <a:masterClrMapping/>
   </p:clrMapOvr>
+  <p:timing>
+    <p:tnLst>
+      <p:par>
+        <p:cTn id="1" dur="indefinite" restart="never" nodeType="tmRoot">
+          <p:childTnLst>
+            <p:seq concurrent="1" nextAc="seek">
+              <p:cTn id="2" dur="indefinite" nodeType="mainSeq">
+                <p:childTnLst>
+                  <p:par>
+                    <p:cTn id="3" fill="hold">
+                      <p:stCondLst>
+                        <p:cond delay="indefinite"/>
+                      </p:stCondLst>
+                      <p:childTnLst>
+                        <p:par>
+                          <p:cTn id="4" fill="hold">
+                            <p:stCondLst>
+                              <p:cond delay="0"/>
+                            </p:stCondLst>
+                            <p:childTnLst>
+                              <p:par>
+                                <p:cTn id="5" presetID="1" presetClass="entr" presetSubtype="0" fill="hold" grpId="0" nodeType="clickEffect">
+                                  <p:stCondLst>
+                                    <p:cond delay="0"/>
+                                  </p:stCondLst>
+                                  <p:childTnLst>
+                                    <p:set>
+                                      <p:cBhvr>
+                                        <p:cTn id="6" dur="1" fill="hold">
+                                          <p:stCondLst>
+                                            <p:cond delay="0"/>
+                                          </p:stCondLst>
+                                        </p:cTn>
+                                        <p:tgtEl>
+                                          <p:spTgt spid="8"/>
+                                        </p:tgtEl>
+                                        <p:attrNameLst>
+                                          <p:attrName>style.visibility</p:attrName>
+                                        </p:attrNameLst>
+                                      </p:cBhvr>
+                                      <p:to>
+                                        <p:strVal val="visible"/>
+                                      </p:to>
+                                    </p:set>
+                                  </p:childTnLst>
+                                </p:cTn>
+                              </p:par>
+                            </p:childTnLst>
+                          </p:cTn>
+                        </p:par>
+                      </p:childTnLst>
+                    </p:cTn>
+                  </p:par>
+                  <p:par>
+                    <p:cTn id="7" fill="hold">
+                      <p:stCondLst>
+                        <p:cond delay="indefinite"/>
+                      </p:stCondLst>
+                      <p:childTnLst>
+                        <p:par>
+                          <p:cTn id="8" fill="hold">
+                            <p:stCondLst>
+                              <p:cond delay="0"/>
+                            </p:stCondLst>
+                            <p:childTnLst>
+                              <p:par>
+                                <p:cTn id="9" presetID="1" presetClass="entr" presetSubtype="0" fill="hold" grpId="0" nodeType="clickEffect">
+                                  <p:stCondLst>
+                                    <p:cond delay="0"/>
+                                  </p:stCondLst>
+                                  <p:childTnLst>
+                                    <p:set>
+                                      <p:cBhvr>
+                                        <p:cTn id="10" dur="1" fill="hold">
+                                          <p:stCondLst>
+                                            <p:cond delay="0"/>
+                                          </p:stCondLst>
+                                        </p:cTn>
+                                        <p:tgtEl>
+                                          <p:spTgt spid="10"/>
+                                        </p:tgtEl>
+                                        <p:attrNameLst>
+                                          <p:attrName>style.visibility</p:attrName>
+                                        </p:attrNameLst>
+                                      </p:cBhvr>
+                                      <p:to>
+                                        <p:strVal val="visible"/>
+                                      </p:to>
+                                    </p:set>
+                                  </p:childTnLst>
+                                </p:cTn>
+                              </p:par>
+                            </p:childTnLst>
+                          </p:cTn>
+                        </p:par>
+                      </p:childTnLst>
+                    </p:cTn>
+                  </p:par>
+                  <p:par>
+                    <p:cTn id="11" fill="hold">
+                      <p:stCondLst>
+                        <p:cond delay="indefinite"/>
+                      </p:stCondLst>
+                      <p:childTnLst>
+                        <p:par>
+                          <p:cTn id="12" fill="hold">
+                            <p:stCondLst>
+                              <p:cond delay="0"/>
+                            </p:stCondLst>
+                            <p:childTnLst>
+                              <p:par>
+                                <p:cTn id="13" presetID="1" presetClass="entr" presetSubtype="0" fill="hold" grpId="0" nodeType="clickEffect">
+                                  <p:stCondLst>
+                                    <p:cond delay="0"/>
+                                  </p:stCondLst>
+                                  <p:childTnLst>
+                                    <p:set>
+                                      <p:cBhvr>
+                                        <p:cTn id="14" dur="1" fill="hold">
+                                          <p:stCondLst>
+                                            <p:cond delay="0"/>
+                                          </p:stCondLst>
+                                        </p:cTn>
+                                        <p:tgtEl>
+                                          <p:spTgt spid="12"/>
+                                        </p:tgtEl>
+                                        <p:attrNameLst>
+                                          <p:attrName>style.visibility</p:attrName>
+                                        </p:attrNameLst>
+                                      </p:cBhvr>
+                                      <p:to>
+                                        <p:strVal val="visible"/>
+                                      </p:to>
+                                    </p:set>
+                                  </p:childTnLst>
+                                </p:cTn>
+                              </p:par>
+                            </p:childTnLst>
+                          </p:cTn>
+                        </p:par>
+                      </p:childTnLst>
+                    </p:cTn>
+                  </p:par>
+                  <p:par>
+                    <p:cTn id="15" fill="hold">
+                      <p:stCondLst>
+                        <p:cond delay="indefinite"/>
+                      </p:stCondLst>
+                      <p:childTnLst>
+                        <p:par>
+                          <p:cTn id="16" fill="hold">
+                            <p:stCondLst>
+                              <p:cond delay="0"/>
+                            </p:stCondLst>
+                            <p:childTnLst>
+                              <p:par>
+                                <p:cTn id="17" presetID="1" presetClass="entr" presetSubtype="0" fill="hold" grpId="0" nodeType="clickEffect">
+                                  <p:stCondLst>
+                                    <p:cond delay="0"/>
+                                  </p:stCondLst>
+                                  <p:childTnLst>
+                                    <p:set>
+                                      <p:cBhvr>
+                                        <p:cTn id="18" dur="1" fill="hold">
+                                          <p:stCondLst>
+                                            <p:cond delay="0"/>
+                                          </p:stCondLst>
+                                        </p:cTn>
+                                        <p:tgtEl>
+                                          <p:spTgt spid="14"/>
+                                        </p:tgtEl>
+                                        <p:attrNameLst>
+                                          <p:attrName>style.visibility</p:attrName>
+                                        </p:attrNameLst>
+                                      </p:cBhvr>
+                                      <p:to>
+                                        <p:strVal val="visible"/>
+                                      </p:to>
+                                    </p:set>
+                                  </p:childTnLst>
+                                </p:cTn>
+                              </p:par>
+                            </p:childTnLst>
+                          </p:cTn>
+                        </p:par>
+                      </p:childTnLst>
+                    </p:cTn>
+                  </p:par>
+                  <p:par>
+                    <p:cTn id="19" fill="hold">
+                      <p:stCondLst>
+                        <p:cond delay="indefinite"/>
+                      </p:stCondLst>
+                      <p:childTnLst>
+                        <p:par>
+                          <p:cTn id="20" fill="hold">
+                            <p:stCondLst>
+                              <p:cond delay="0"/>
+                            </p:stCondLst>
+                            <p:childTnLst>
+                              <p:par>
+                                <p:cTn id="21" presetID="1" presetClass="entr" presetSubtype="0" fill="hold" grpId="0" nodeType="clickEffect">
+                                  <p:stCondLst>
+                                    <p:cond delay="0"/>
+                                  </p:stCondLst>
+                                  <p:childTnLst>
+                                    <p:set>
+                                      <p:cBhvr>
+                                        <p:cTn id="22" dur="1" fill="hold">
+                                          <p:stCondLst>
+                                            <p:cond delay="0"/>
+                                          </p:stCondLst>
+                                        </p:cTn>
+                                        <p:tgtEl>
+                                          <p:spTgt spid="16"/>
+                                        </p:tgtEl>
+                                        <p:attrNameLst>
+                                          <p:attrName>style.visibility</p:attrName>
+                                        </p:attrNameLst>
+                                      </p:cBhvr>
+                                      <p:to>
+                                        <p:strVal val="visible"/>
+                                      </p:to>
+                                    </p:set>
+                                  </p:childTnLst>
+                                </p:cTn>
+                              </p:par>
+                            </p:childTnLst>
+                          </p:cTn>
+                        </p:par>
+                      </p:childTnLst>
+                    </p:cTn>
+                  </p:par>
+                </p:childTnLst>
+              </p:cTn>
+              <p:prevCondLst>
+                <p:cond evt="onPrev" delay="0">
+                  <p:tgtEl>
+                    <p:sldTgt/>
+                  </p:tgtEl>
+                </p:cond>
+              </p:prevCondLst>
+              <p:nextCondLst>
+                <p:cond evt="onNext" delay="0">
+                  <p:tgtEl>
+                    <p:sldTgt/>
+                  </p:tgtEl>
+                </p:cond>
+              </p:nextCondLst>
+            </p:seq>
+          </p:childTnLst>
+        </p:cTn>
+      </p:par>
+    </p:tnLst>
+    <p:bldLst>
+      <p:bldP spid="8" grpId="0" animBg="1"/>
+      <p:bldP spid="10" grpId="0" animBg="1"/>
+      <p:bldP spid="12" grpId="0" animBg="1"/>
+      <p:bldP spid="14" grpId="0" animBg="1"/>
+      <p:bldP spid="16" grpId="0" animBg="1"/>
+    </p:bldLst>
+  </p:timing>
 </p:sld>
 </file>
 
@@ -17173,6 +17568,268 @@
 
 <file path=ppt/slides/slide37.xml><?xml version="1.0" encoding="utf-8"?>
 <p:sld xmlns:a="http://schemas.openxmlformats.org/drawingml/2006/main" xmlns:r="http://schemas.openxmlformats.org/officeDocument/2006/relationships" xmlns:p="http://schemas.openxmlformats.org/presentationml/2006/main">
+  <p:cSld name="Slide 38">
+    <p:bg>
+      <p:bgPr>
+        <a:solidFill>
+          <a:srgbClr val="161D2D"/>
+        </a:solidFill>
+        <a:effectLst/>
+      </p:bgPr>
+    </p:bg>
+    <p:spTree>
+      <p:nvGrpSpPr>
+        <p:cNvPr id="1" name=""/>
+        <p:cNvGrpSpPr/>
+        <p:nvPr/>
+      </p:nvGrpSpPr>
+      <p:grpSpPr>
+        <a:xfrm>
+          <a:off x="0" y="0"/>
+          <a:ext cx="0" cy="0"/>
+          <a:chOff x="0" y="0"/>
+          <a:chExt cx="0" cy="0"/>
+        </a:xfrm>
+      </p:grpSpPr>
+      <p:sp>
+        <p:nvSpPr>
+          <p:cNvPr id="3" name="Text 0"/>
+          <p:cNvSpPr/>
+          <p:nvPr/>
+        </p:nvSpPr>
+        <p:spPr>
+          <a:xfrm>
+            <a:off x="548640" y="6291072"/>
+            <a:ext cx="3657600" cy="274320"/>
+          </a:xfrm>
+          <a:prstGeom prst="rect">
+            <a:avLst/>
+          </a:prstGeom>
+          <a:noFill/>
+          <a:ln/>
+        </p:spPr>
+        <p:txBody>
+          <a:bodyPr wrap="square" lIns="0" tIns="0" rIns="0" bIns="0" rtlCol="0" anchor="ctr"/>
+          <a:lstStyle/>
+          <a:p>
+            <a:pPr marL="0" indent="0" algn="l">
+              <a:buNone/>
+            </a:pPr>
+            <a:r>
+              <a:rPr lang="en-US" sz="1000" dirty="0">
+                <a:solidFill>
+                  <a:srgbClr val="48536B"/>
+                </a:solidFill>
+                <a:latin typeface="Arial" pitchFamily="34" charset="0"/>
+                <a:ea typeface="Arial" pitchFamily="34" charset="-122"/>
+                <a:cs typeface="Arial" pitchFamily="34" charset="-120"/>
+              </a:rPr>
+              <a:t>6.4  ·  38:48–39:58</a:t>
+            </a:r>
+            <a:endParaRPr lang="en-US" sz="1000" dirty="0"/>
+          </a:p>
+        </p:txBody>
+      </p:sp>
+      <p:sp>
+        <p:nvSpPr>
+          <p:cNvPr id="4" name="Text 1"/>
+          <p:cNvSpPr/>
+          <p:nvPr/>
+        </p:nvSpPr>
+        <p:spPr>
+          <a:xfrm>
+            <a:off x="10042855" y="6291072"/>
+            <a:ext cx="914400" cy="274320"/>
+          </a:xfrm>
+          <a:prstGeom prst="rect">
+            <a:avLst/>
+          </a:prstGeom>
+          <a:noFill/>
+          <a:ln/>
+        </p:spPr>
+        <p:txBody>
+          <a:bodyPr wrap="square" lIns="0" tIns="0" rIns="0" bIns="0" rtlCol="0" anchor="ctr"/>
+          <a:lstStyle/>
+          <a:p>
+            <a:pPr marL="0" indent="0" algn="r">
+              <a:buNone/>
+            </a:pPr>
+            <a:r>
+              <a:rPr lang="en-US" sz="1000" dirty="0">
+                <a:solidFill>
+                  <a:srgbClr val="48536B"/>
+                </a:solidFill>
+                <a:latin typeface="Arial" pitchFamily="34" charset="0"/>
+                <a:ea typeface="Arial" pitchFamily="34" charset="-122"/>
+                <a:cs typeface="Arial" pitchFamily="34" charset="-120"/>
+              </a:rPr>
+              <a:t>38/38</a:t>
+            </a:r>
+            <a:endParaRPr lang="en-US" sz="1000" dirty="0"/>
+          </a:p>
+        </p:txBody>
+      </p:sp>
+      <p:pic>
+        <p:nvPicPr>
+          <p:cNvPr id="5" name="Image 0" descr="/sessions/awesome-wizardly-sagan/mnt/charla-ia-aws-ug-cucuta/multimedia/aws_ug_cucuta_logo.jpeg"/>
+          <p:cNvPicPr>
+            <a:picLocks noChangeAspect="1"/>
+          </p:cNvPicPr>
+          <p:nvPr/>
+        </p:nvPicPr>
+        <p:blipFill>
+          <a:blip r:embed="rId3">
+            <a:alphaModFix amt="75000"/>
+          </a:blip>
+          <a:stretch>
+            <a:fillRect/>
+          </a:stretch>
+        </p:blipFill>
+        <p:spPr>
+          <a:xfrm>
+            <a:off x="11231575" y="6071616"/>
+            <a:ext cx="457200" cy="457200"/>
+          </a:xfrm>
+          <a:prstGeom prst="rect">
+            <a:avLst/>
+          </a:prstGeom>
+        </p:spPr>
+      </p:pic>
+      <p:sp>
+        <p:nvSpPr>
+          <p:cNvPr id="6" name="Text 2"/>
+          <p:cNvSpPr/>
+          <p:nvPr/>
+        </p:nvSpPr>
+        <p:spPr>
+          <a:xfrm>
+            <a:off x="914400" y="1920240"/>
+            <a:ext cx="10362895" cy="2011680"/>
+          </a:xfrm>
+          <a:prstGeom prst="rect">
+            <a:avLst/>
+          </a:prstGeom>
+          <a:noFill/>
+          <a:ln/>
+        </p:spPr>
+        <p:txBody>
+          <a:bodyPr wrap="square" lIns="0" tIns="0" rIns="0" bIns="0" rtlCol="0" anchor="ctr"/>
+          <a:lstStyle/>
+          <a:p>
+            <a:pPr marL="0" indent="0" algn="ctr">
+              <a:lnSpc>
+                <a:spcPts val="5400"/>
+              </a:lnSpc>
+              <a:buNone/>
+            </a:pPr>
+            <a:r>
+              <a:rPr lang="en-US" sz="4000" b="1" dirty="0">
+                <a:solidFill>
+                  <a:srgbClr val="FFFFFF"/>
+                </a:solidFill>
+                <a:latin typeface="Arial" pitchFamily="34" charset="0"/>
+                <a:ea typeface="Arial" pitchFamily="34" charset="-122"/>
+                <a:cs typeface="Arial" pitchFamily="34" charset="-120"/>
+              </a:rPr>
+              <a:t>Don't compete with AI at writing code.</a:t>
+            </a:r>
+            <a:endParaRPr lang="en-US" sz="4000" dirty="0"/>
+          </a:p>
+          <a:p>
+            <a:pPr marL="0" indent="0" algn="ctr">
+              <a:lnSpc>
+                <a:spcPts val="5400"/>
+              </a:lnSpc>
+              <a:buNone/>
+            </a:pPr>
+            <a:r>
+              <a:rPr lang="en-US" sz="4000" b="1" dirty="0">
+                <a:solidFill>
+                  <a:srgbClr val="9257F1"/>
+                </a:solidFill>
+                <a:latin typeface="Arial" pitchFamily="34" charset="0"/>
+                <a:ea typeface="Arial" pitchFamily="34" charset="-122"/>
+                <a:cs typeface="Arial" pitchFamily="34" charset="-120"/>
+              </a:rPr>
+              <a:t>Learn to build what matters.</a:t>
+            </a:r>
+            <a:endParaRPr lang="en-US" sz="4000" dirty="0"/>
+          </a:p>
+        </p:txBody>
+      </p:sp>
+      <p:sp>
+        <p:nvSpPr>
+          <p:cNvPr id="7" name="Text 3"/>
+          <p:cNvSpPr/>
+          <p:nvPr/>
+        </p:nvSpPr>
+        <p:spPr>
+          <a:xfrm>
+            <a:off x="914400" y="4206240"/>
+            <a:ext cx="10362895" cy="548640"/>
+          </a:xfrm>
+          <a:prstGeom prst="rect">
+            <a:avLst/>
+          </a:prstGeom>
+          <a:noFill/>
+          <a:ln/>
+        </p:spPr>
+        <p:txBody>
+          <a:bodyPr wrap="square" lIns="0" tIns="0" rIns="0" bIns="0" rtlCol="0" anchor="ctr"/>
+          <a:lstStyle/>
+          <a:p>
+            <a:pPr marL="0" indent="0" algn="ctr">
+              <a:buNone/>
+            </a:pPr>
+            <a:r>
+              <a:rPr lang="en-US" sz="2200" dirty="0">
+                <a:solidFill>
+                  <a:srgbClr val="8A93A8"/>
+                </a:solidFill>
+                <a:latin typeface="Arial" pitchFamily="34" charset="0"/>
+                <a:ea typeface="Arial" pitchFamily="34" charset="-122"/>
+                <a:cs typeface="Arial" pitchFamily="34" charset="-120"/>
+              </a:rPr>
+              <a:t>Ingeniería  +  Cloud  +  IA  +  criterio.</a:t>
+            </a:r>
+            <a:endParaRPr lang="en-US" sz="2200" dirty="0"/>
+          </a:p>
+        </p:txBody>
+      </p:sp>
+      <p:pic>
+        <p:nvPicPr>
+          <p:cNvPr id="8" name="Image 1" descr="/sessions/awesome-wizardly-sagan/mnt/charla-ia-aws-ug-cucuta/multimedia/aws_ug_cucuta_logo.jpeg"/>
+          <p:cNvPicPr>
+            <a:picLocks noChangeAspect="1"/>
+          </p:cNvPicPr>
+          <p:nvPr/>
+        </p:nvPicPr>
+        <p:blipFill>
+          <a:blip r:embed="rId3"/>
+          <a:stretch>
+            <a:fillRect/>
+          </a:stretch>
+        </p:blipFill>
+        <p:spPr>
+          <a:xfrm>
+            <a:off x="5661508" y="5074920"/>
+            <a:ext cx="868680" cy="868680"/>
+          </a:xfrm>
+          <a:prstGeom prst="rect">
+            <a:avLst/>
+          </a:prstGeom>
+        </p:spPr>
+      </p:pic>
+    </p:spTree>
+  </p:cSld>
+  <p:clrMapOvr>
+    <a:masterClrMapping/>
+  </p:clrMapOvr>
+</p:sld>
+</file>
+
+<file path=ppt/slides/slide38.xml><?xml version="1.0" encoding="utf-8"?>
+<p:sld xmlns:a="http://schemas.openxmlformats.org/drawingml/2006/main" xmlns:r="http://schemas.openxmlformats.org/officeDocument/2006/relationships" xmlns:p="http://schemas.openxmlformats.org/presentationml/2006/main">
   <p:cSld name="Slide 37">
     <p:bg>
       <p:bgPr>
@@ -17339,262 +17996,30 @@
           </a:p>
         </p:txBody>
       </p:sp>
-    </p:spTree>
-  </p:cSld>
-  <p:clrMapOvr>
-    <a:masterClrMapping/>
-  </p:clrMapOvr>
-</p:sld>
-</file>
-
-<file path=ppt/slides/slide38.xml><?xml version="1.0" encoding="utf-8"?>
-<p:sld xmlns:a="http://schemas.openxmlformats.org/drawingml/2006/main" xmlns:r="http://schemas.openxmlformats.org/officeDocument/2006/relationships" xmlns:p="http://schemas.openxmlformats.org/presentationml/2006/main">
-  <p:cSld name="Slide 38">
-    <p:bg>
-      <p:bgPr>
-        <a:solidFill>
-          <a:srgbClr val="161D2D"/>
-        </a:solidFill>
-        <a:effectLst/>
-      </p:bgPr>
-    </p:bg>
-    <p:spTree>
-      <p:nvGrpSpPr>
-        <p:cNvPr id="1" name=""/>
-        <p:cNvGrpSpPr/>
-        <p:nvPr/>
-      </p:nvGrpSpPr>
-      <p:grpSpPr>
-        <a:xfrm>
-          <a:off x="0" y="0"/>
-          <a:ext cx="0" cy="0"/>
-          <a:chOff x="0" y="0"/>
-          <a:chExt cx="0" cy="0"/>
-        </a:xfrm>
-      </p:grpSpPr>
-      <p:sp>
-        <p:nvSpPr>
-          <p:cNvPr id="3" name="Text 0"/>
-          <p:cNvSpPr/>
-          <p:nvPr/>
-        </p:nvSpPr>
-        <p:spPr>
-          <a:xfrm>
-            <a:off x="548640" y="6291072"/>
-            <a:ext cx="3657600" cy="274320"/>
-          </a:xfrm>
-          <a:prstGeom prst="rect">
-            <a:avLst/>
-          </a:prstGeom>
-          <a:noFill/>
-          <a:ln/>
-        </p:spPr>
-        <p:txBody>
-          <a:bodyPr wrap="square" lIns="0" tIns="0" rIns="0" bIns="0" rtlCol="0" anchor="ctr"/>
-          <a:lstStyle/>
-          <a:p>
-            <a:pPr marL="0" indent="0" algn="l">
-              <a:buNone/>
-            </a:pPr>
-            <a:r>
-              <a:rPr lang="en-US" sz="1000" dirty="0">
-                <a:solidFill>
-                  <a:srgbClr val="48536B"/>
-                </a:solidFill>
-                <a:latin typeface="Arial" pitchFamily="34" charset="0"/>
-                <a:ea typeface="Arial" pitchFamily="34" charset="-122"/>
-                <a:cs typeface="Arial" pitchFamily="34" charset="-120"/>
-              </a:rPr>
-              <a:t>6.4  ·  38:48–39:58</a:t>
-            </a:r>
-            <a:endParaRPr lang="en-US" sz="1000" dirty="0"/>
-          </a:p>
-        </p:txBody>
-      </p:sp>
-      <p:sp>
-        <p:nvSpPr>
-          <p:cNvPr id="4" name="Text 1"/>
-          <p:cNvSpPr/>
-          <p:nvPr/>
-        </p:nvSpPr>
-        <p:spPr>
-          <a:xfrm>
-            <a:off x="10042855" y="6291072"/>
-            <a:ext cx="914400" cy="274320"/>
-          </a:xfrm>
-          <a:prstGeom prst="rect">
-            <a:avLst/>
-          </a:prstGeom>
-          <a:noFill/>
-          <a:ln/>
-        </p:spPr>
-        <p:txBody>
-          <a:bodyPr wrap="square" lIns="0" tIns="0" rIns="0" bIns="0" rtlCol="0" anchor="ctr"/>
-          <a:lstStyle/>
-          <a:p>
-            <a:pPr marL="0" indent="0" algn="r">
-              <a:buNone/>
-            </a:pPr>
-            <a:r>
-              <a:rPr lang="en-US" sz="1000" dirty="0">
-                <a:solidFill>
-                  <a:srgbClr val="48536B"/>
-                </a:solidFill>
-                <a:latin typeface="Arial" pitchFamily="34" charset="0"/>
-                <a:ea typeface="Arial" pitchFamily="34" charset="-122"/>
-                <a:cs typeface="Arial" pitchFamily="34" charset="-120"/>
-              </a:rPr>
-              <a:t>38/38</a:t>
-            </a:r>
-            <a:endParaRPr lang="en-US" sz="1000" dirty="0"/>
-          </a:p>
-        </p:txBody>
-      </p:sp>
       <p:pic>
         <p:nvPicPr>
-          <p:cNvPr id="5" name="Image 0" descr="/sessions/awesome-wizardly-sagan/mnt/charla-ia-aws-ug-cucuta/multimedia/aws_ug_cucuta_logo.jpeg"/>
+          <p:cNvPr id="9" name="Picture 8">
+            <a:extLst>
+              <a:ext uri="{FF2B5EF4-FFF2-40B4-BE49-F238E27FC236}">
+                <a16:creationId xmlns:a16="http://schemas.microsoft.com/office/drawing/2014/main" id="{4728CE6E-59B2-E306-436E-E50C0866240B}"/>
+              </a:ext>
+            </a:extLst>
+          </p:cNvPr>
           <p:cNvPicPr>
             <a:picLocks noChangeAspect="1"/>
           </p:cNvPicPr>
           <p:nvPr/>
         </p:nvPicPr>
         <p:blipFill>
-          <a:blip r:embed="rId3">
-            <a:alphaModFix amt="75000"/>
-          </a:blip>
+          <a:blip r:embed="rId4"/>
           <a:stretch>
             <a:fillRect/>
           </a:stretch>
         </p:blipFill>
         <p:spPr>
           <a:xfrm>
-            <a:off x="11231575" y="6071616"/>
-            <a:ext cx="457200" cy="457200"/>
-          </a:xfrm>
-          <a:prstGeom prst="rect">
-            <a:avLst/>
-          </a:prstGeom>
-        </p:spPr>
-      </p:pic>
-      <p:sp>
-        <p:nvSpPr>
-          <p:cNvPr id="6" name="Text 2"/>
-          <p:cNvSpPr/>
-          <p:nvPr/>
-        </p:nvSpPr>
-        <p:spPr>
-          <a:xfrm>
-            <a:off x="914400" y="1920240"/>
-            <a:ext cx="10362895" cy="2011680"/>
-          </a:xfrm>
-          <a:prstGeom prst="rect">
-            <a:avLst/>
-          </a:prstGeom>
-          <a:noFill/>
-          <a:ln/>
-        </p:spPr>
-        <p:txBody>
-          <a:bodyPr wrap="square" lIns="0" tIns="0" rIns="0" bIns="0" rtlCol="0" anchor="ctr"/>
-          <a:lstStyle/>
-          <a:p>
-            <a:pPr marL="0" indent="0" algn="ctr">
-              <a:lnSpc>
-                <a:spcPts val="5400"/>
-              </a:lnSpc>
-              <a:buNone/>
-            </a:pPr>
-            <a:r>
-              <a:rPr lang="en-US" sz="4000" b="1" dirty="0">
-                <a:solidFill>
-                  <a:srgbClr val="FFFFFF"/>
-                </a:solidFill>
-                <a:latin typeface="Arial" pitchFamily="34" charset="0"/>
-                <a:ea typeface="Arial" pitchFamily="34" charset="-122"/>
-                <a:cs typeface="Arial" pitchFamily="34" charset="-120"/>
-              </a:rPr>
-              <a:t>Don't compete with AI at writing code.</a:t>
-            </a:r>
-            <a:endParaRPr lang="en-US" sz="4000" dirty="0"/>
-          </a:p>
-          <a:p>
-            <a:pPr marL="0" indent="0" algn="ctr">
-              <a:lnSpc>
-                <a:spcPts val="5400"/>
-              </a:lnSpc>
-              <a:buNone/>
-            </a:pPr>
-            <a:r>
-              <a:rPr lang="en-US" sz="4000" b="1" dirty="0">
-                <a:solidFill>
-                  <a:srgbClr val="9257F1"/>
-                </a:solidFill>
-                <a:latin typeface="Arial" pitchFamily="34" charset="0"/>
-                <a:ea typeface="Arial" pitchFamily="34" charset="-122"/>
-                <a:cs typeface="Arial" pitchFamily="34" charset="-120"/>
-              </a:rPr>
-              <a:t>Learn to build what matters.</a:t>
-            </a:r>
-            <a:endParaRPr lang="en-US" sz="4000" dirty="0"/>
-          </a:p>
-        </p:txBody>
-      </p:sp>
-      <p:sp>
-        <p:nvSpPr>
-          <p:cNvPr id="7" name="Text 3"/>
-          <p:cNvSpPr/>
-          <p:nvPr/>
-        </p:nvSpPr>
-        <p:spPr>
-          <a:xfrm>
-            <a:off x="914400" y="4206240"/>
-            <a:ext cx="10362895" cy="548640"/>
-          </a:xfrm>
-          <a:prstGeom prst="rect">
-            <a:avLst/>
-          </a:prstGeom>
-          <a:noFill/>
-          <a:ln/>
-        </p:spPr>
-        <p:txBody>
-          <a:bodyPr wrap="square" lIns="0" tIns="0" rIns="0" bIns="0" rtlCol="0" anchor="ctr"/>
-          <a:lstStyle/>
-          <a:p>
-            <a:pPr marL="0" indent="0" algn="ctr">
-              <a:buNone/>
-            </a:pPr>
-            <a:r>
-              <a:rPr lang="en-US" sz="2200" dirty="0">
-                <a:solidFill>
-                  <a:srgbClr val="8A93A8"/>
-                </a:solidFill>
-                <a:latin typeface="Arial" pitchFamily="34" charset="0"/>
-                <a:ea typeface="Arial" pitchFamily="34" charset="-122"/>
-                <a:cs typeface="Arial" pitchFamily="34" charset="-120"/>
-              </a:rPr>
-              <a:t>Ingeniería  +  Cloud  +  IA  +  criterio.</a:t>
-            </a:r>
-            <a:endParaRPr lang="en-US" sz="2200" dirty="0"/>
-          </a:p>
-        </p:txBody>
-      </p:sp>
-      <p:pic>
-        <p:nvPicPr>
-          <p:cNvPr id="8" name="Image 1" descr="/sessions/awesome-wizardly-sagan/mnt/charla-ia-aws-ug-cucuta/multimedia/aws_ug_cucuta_logo.jpeg"/>
-          <p:cNvPicPr>
-            <a:picLocks noChangeAspect="1"/>
-          </p:cNvPicPr>
-          <p:nvPr/>
-        </p:nvPicPr>
-        <p:blipFill>
-          <a:blip r:embed="rId3"/>
-          <a:stretch>
-            <a:fillRect/>
-          </a:stretch>
-        </p:blipFill>
-        <p:spPr>
-          <a:xfrm>
-            <a:off x="5661508" y="5074920"/>
-            <a:ext cx="868680" cy="868680"/>
+            <a:off x="3657600" y="990600"/>
+            <a:ext cx="4876800" cy="4876800"/>
           </a:xfrm>
           <a:prstGeom prst="rect">
             <a:avLst/>
@@ -18898,7 +19323,7 @@
                 <a:ea typeface="Arial" pitchFamily="34" charset="-122"/>
                 <a:cs typeface="Arial" pitchFamily="34" charset="-120"/>
               </a:rPr>
-              <a:t> Código </a:t>
+              <a:t> </a:t>
             </a:r>
             <a:r>
               <a:rPr lang="en-US" sz="2800" b="1" dirty="0" err="1">
@@ -18909,6 +19334,28 @@
                 <a:ea typeface="Arial" pitchFamily="34" charset="-122"/>
                 <a:cs typeface="Arial" pitchFamily="34" charset="-120"/>
               </a:rPr>
+              <a:t>código</a:t>
+            </a:r>
+            <a:r>
+              <a:rPr lang="en-US" sz="2800" b="1" dirty="0">
+                <a:solidFill>
+                  <a:srgbClr val="9257F1"/>
+                </a:solidFill>
+                <a:latin typeface="Arial" pitchFamily="34" charset="0"/>
+                <a:ea typeface="Arial" pitchFamily="34" charset="-122"/>
+                <a:cs typeface="Arial" pitchFamily="34" charset="-120"/>
+              </a:rPr>
+              <a:t> </a:t>
+            </a:r>
+            <a:r>
+              <a:rPr lang="en-US" sz="2800" b="1" dirty="0" err="1">
+                <a:solidFill>
+                  <a:srgbClr val="9257F1"/>
+                </a:solidFill>
+                <a:latin typeface="Arial" pitchFamily="34" charset="0"/>
+                <a:ea typeface="Arial" pitchFamily="34" charset="-122"/>
+                <a:cs typeface="Arial" pitchFamily="34" charset="-120"/>
+              </a:rPr>
               <a:t>deja</a:t>
             </a:r>
             <a:r>
@@ -18964,7 +19411,29 @@
                 <a:ea typeface="Arial" pitchFamily="34" charset="-122"/>
                 <a:cs typeface="Arial" pitchFamily="34" charset="-120"/>
               </a:rPr>
-              <a:t> competitive </a:t>
+              <a:t> </a:t>
+            </a:r>
+            <a:r>
+              <a:rPr lang="en-US" sz="2800" b="1" dirty="0" err="1">
+                <a:solidFill>
+                  <a:srgbClr val="9257F1"/>
+                </a:solidFill>
+                <a:latin typeface="Arial" pitchFamily="34" charset="0"/>
+                <a:ea typeface="Arial" pitchFamily="34" charset="-122"/>
+                <a:cs typeface="Arial" pitchFamily="34" charset="-120"/>
+              </a:rPr>
+              <a:t>competitiva</a:t>
+            </a:r>
+            <a:r>
+              <a:rPr lang="en-US" sz="2800" b="1" dirty="0">
+                <a:solidFill>
+                  <a:srgbClr val="9257F1"/>
+                </a:solidFill>
+                <a:latin typeface="Arial" pitchFamily="34" charset="0"/>
+                <a:ea typeface="Arial" pitchFamily="34" charset="-122"/>
+                <a:cs typeface="Arial" pitchFamily="34" charset="-120"/>
+              </a:rPr>
+              <a:t> </a:t>
             </a:r>
             <a:r>
               <a:rPr lang="en-US" sz="3600" b="1" dirty="0">
@@ -19262,345 +19731,408 @@
           </a:p>
         </p:txBody>
       </p:sp>
-      <p:sp>
-        <p:nvSpPr>
-          <p:cNvPr id="8" name="Shape 4"/>
-          <p:cNvSpPr/>
-          <p:nvPr/>
-        </p:nvSpPr>
-        <p:spPr>
+      <p:grpSp>
+        <p:nvGrpSpPr>
+          <p:cNvPr id="2" name="Group 1">
+            <a:extLst>
+              <a:ext uri="{FF2B5EF4-FFF2-40B4-BE49-F238E27FC236}">
+                <a16:creationId xmlns:a16="http://schemas.microsoft.com/office/drawing/2014/main" id="{732E9A59-E852-9D83-7D00-A05748C5E1D5}"/>
+              </a:ext>
+            </a:extLst>
+          </p:cNvPr>
+          <p:cNvGrpSpPr/>
+          <p:nvPr/>
+        </p:nvGrpSpPr>
+        <p:grpSpPr>
           <a:xfrm>
             <a:off x="822960" y="2148840"/>
             <a:ext cx="3301898" cy="3200400"/>
-          </a:xfrm>
-          <a:prstGeom prst="rect">
-            <a:avLst/>
-          </a:prstGeom>
-          <a:solidFill>
-            <a:srgbClr val="1E2739"/>
-          </a:solidFill>
-          <a:ln w="12700">
+            <a:chOff x="822960" y="2148840"/>
+            <a:chExt cx="3301898" cy="3200400"/>
+          </a:xfrm>
+        </p:grpSpPr>
+        <p:sp>
+          <p:nvSpPr>
+            <p:cNvPr id="8" name="Shape 4"/>
+            <p:cNvSpPr/>
+            <p:nvPr/>
+          </p:nvSpPr>
+          <p:spPr>
+            <a:xfrm>
+              <a:off x="822960" y="2148840"/>
+              <a:ext cx="3301898" cy="3200400"/>
+            </a:xfrm>
+            <a:prstGeom prst="rect">
+              <a:avLst/>
+            </a:prstGeom>
             <a:solidFill>
-              <a:srgbClr val="2C3852"/>
+              <a:srgbClr val="1E2739"/>
             </a:solidFill>
-            <a:prstDash val="solid"/>
-          </a:ln>
-        </p:spPr>
-        <p:txBody>
-          <a:bodyPr/>
-          <a:lstStyle/>
-          <a:p>
-            <a:endParaRPr lang="en-CO"/>
-          </a:p>
-        </p:txBody>
-      </p:sp>
-      <p:sp>
-        <p:nvSpPr>
-          <p:cNvPr id="9" name="Text 5"/>
-          <p:cNvSpPr/>
-          <p:nvPr/>
-        </p:nvSpPr>
-        <p:spPr>
-          <a:xfrm>
-            <a:off x="1143000" y="2468880"/>
-            <a:ext cx="2661818" cy="320040"/>
-          </a:xfrm>
-          <a:prstGeom prst="rect">
-            <a:avLst/>
-          </a:prstGeom>
-          <a:noFill/>
-          <a:ln/>
-        </p:spPr>
-        <p:txBody>
-          <a:bodyPr wrap="square" lIns="0" tIns="0" rIns="0" bIns="0" rtlCol="0" anchor="ctr"/>
-          <a:lstStyle/>
-          <a:p>
-            <a:pPr marL="0" indent="0">
-              <a:buNone/>
-            </a:pPr>
-            <a:r>
-              <a:rPr lang="en-US" sz="1200" b="1" kern="0" spc="200" dirty="0">
-                <a:solidFill>
-                  <a:srgbClr val="9257F1"/>
-                </a:solidFill>
-                <a:latin typeface="Arial" pitchFamily="34" charset="0"/>
-                <a:ea typeface="Arial" pitchFamily="34" charset="-122"/>
-                <a:cs typeface="Arial" pitchFamily="34" charset="-120"/>
-              </a:rPr>
-              <a:t>ESTUDIANTES</a:t>
-            </a:r>
-            <a:endParaRPr lang="en-US" sz="1200" dirty="0"/>
-          </a:p>
-        </p:txBody>
-      </p:sp>
-      <p:sp>
-        <p:nvSpPr>
-          <p:cNvPr id="10" name="Text 6"/>
-          <p:cNvSpPr/>
-          <p:nvPr/>
-        </p:nvSpPr>
-        <p:spPr>
-          <a:xfrm>
-            <a:off x="1143000" y="2926080"/>
-            <a:ext cx="2661818" cy="2057400"/>
-          </a:xfrm>
-          <a:prstGeom prst="rect">
-            <a:avLst/>
-          </a:prstGeom>
-          <a:noFill/>
-          <a:ln/>
-        </p:spPr>
-        <p:txBody>
-          <a:bodyPr wrap="square" lIns="0" tIns="0" rIns="0" bIns="0" rtlCol="0" anchor="t"/>
-          <a:lstStyle/>
-          <a:p>
-            <a:pPr marL="0" indent="0">
-              <a:lnSpc>
-                <a:spcPts val="2600"/>
-              </a:lnSpc>
-              <a:buNone/>
-            </a:pPr>
-            <a:r>
-              <a:rPr lang="en-US" sz="2000" b="1" dirty="0">
-                <a:solidFill>
-                  <a:srgbClr val="FFFFFF"/>
-                </a:solidFill>
-                <a:latin typeface="Arial" pitchFamily="34" charset="0"/>
-                <a:ea typeface="Arial" pitchFamily="34" charset="-122"/>
-                <a:cs typeface="Arial" pitchFamily="34" charset="-120"/>
-              </a:rPr>
-              <a:t>¿Para qué estoy aprendiendo a programar?</a:t>
-            </a:r>
-            <a:endParaRPr lang="en-US" sz="2000" dirty="0"/>
-          </a:p>
-        </p:txBody>
-      </p:sp>
-      <p:sp>
-        <p:nvSpPr>
-          <p:cNvPr id="11" name="Shape 7"/>
-          <p:cNvSpPr/>
-          <p:nvPr/>
-        </p:nvSpPr>
-        <p:spPr>
+            <a:ln w="12700">
+              <a:solidFill>
+                <a:srgbClr val="2C3852"/>
+              </a:solidFill>
+              <a:prstDash val="solid"/>
+            </a:ln>
+          </p:spPr>
+          <p:txBody>
+            <a:bodyPr/>
+            <a:lstStyle/>
+            <a:p>
+              <a:endParaRPr lang="en-CO"/>
+            </a:p>
+          </p:txBody>
+        </p:sp>
+        <p:sp>
+          <p:nvSpPr>
+            <p:cNvPr id="9" name="Text 5"/>
+            <p:cNvSpPr/>
+            <p:nvPr/>
+          </p:nvSpPr>
+          <p:spPr>
+            <a:xfrm>
+              <a:off x="1143000" y="2468880"/>
+              <a:ext cx="2661818" cy="320040"/>
+            </a:xfrm>
+            <a:prstGeom prst="rect">
+              <a:avLst/>
+            </a:prstGeom>
+            <a:noFill/>
+            <a:ln/>
+          </p:spPr>
+          <p:txBody>
+            <a:bodyPr wrap="square" lIns="0" tIns="0" rIns="0" bIns="0" rtlCol="0" anchor="ctr"/>
+            <a:lstStyle/>
+            <a:p>
+              <a:pPr marL="0" indent="0">
+                <a:buNone/>
+              </a:pPr>
+              <a:r>
+                <a:rPr lang="en-US" sz="1200" b="1" kern="0" spc="200" dirty="0">
+                  <a:solidFill>
+                    <a:srgbClr val="9257F1"/>
+                  </a:solidFill>
+                  <a:latin typeface="Arial" pitchFamily="34" charset="0"/>
+                  <a:ea typeface="Arial" pitchFamily="34" charset="-122"/>
+                  <a:cs typeface="Arial" pitchFamily="34" charset="-120"/>
+                </a:rPr>
+                <a:t>ESTUDIANTES</a:t>
+              </a:r>
+              <a:endParaRPr lang="en-US" sz="1200" dirty="0"/>
+            </a:p>
+          </p:txBody>
+        </p:sp>
+        <p:sp>
+          <p:nvSpPr>
+            <p:cNvPr id="10" name="Text 6"/>
+            <p:cNvSpPr/>
+            <p:nvPr/>
+          </p:nvSpPr>
+          <p:spPr>
+            <a:xfrm>
+              <a:off x="1143000" y="2926080"/>
+              <a:ext cx="2661818" cy="2057400"/>
+            </a:xfrm>
+            <a:prstGeom prst="rect">
+              <a:avLst/>
+            </a:prstGeom>
+            <a:noFill/>
+            <a:ln/>
+          </p:spPr>
+          <p:txBody>
+            <a:bodyPr wrap="square" lIns="0" tIns="0" rIns="0" bIns="0" rtlCol="0" anchor="t"/>
+            <a:lstStyle/>
+            <a:p>
+              <a:pPr marL="0" indent="0">
+                <a:lnSpc>
+                  <a:spcPts val="2600"/>
+                </a:lnSpc>
+                <a:buNone/>
+              </a:pPr>
+              <a:r>
+                <a:rPr lang="en-US" sz="2000" b="1" dirty="0">
+                  <a:solidFill>
+                    <a:srgbClr val="FFFFFF"/>
+                  </a:solidFill>
+                  <a:latin typeface="Arial" pitchFamily="34" charset="0"/>
+                  <a:ea typeface="Arial" pitchFamily="34" charset="-122"/>
+                  <a:cs typeface="Arial" pitchFamily="34" charset="-120"/>
+                </a:rPr>
+                <a:t>¿Para qué estoy aprendiendo a programar?</a:t>
+              </a:r>
+              <a:endParaRPr lang="en-US" sz="2000" dirty="0"/>
+            </a:p>
+          </p:txBody>
+        </p:sp>
+      </p:grpSp>
+      <p:grpSp>
+        <p:nvGrpSpPr>
+          <p:cNvPr id="17" name="Group 16">
+            <a:extLst>
+              <a:ext uri="{FF2B5EF4-FFF2-40B4-BE49-F238E27FC236}">
+                <a16:creationId xmlns:a16="http://schemas.microsoft.com/office/drawing/2014/main" id="{C91EF9BC-BEFE-CC83-F411-C192C3B4DB94}"/>
+              </a:ext>
+            </a:extLst>
+          </p:cNvPr>
+          <p:cNvGrpSpPr/>
+          <p:nvPr/>
+        </p:nvGrpSpPr>
+        <p:grpSpPr>
           <a:xfrm>
             <a:off x="4444898" y="2148840"/>
             <a:ext cx="3301898" cy="3200400"/>
-          </a:xfrm>
-          <a:prstGeom prst="rect">
-            <a:avLst/>
-          </a:prstGeom>
-          <a:solidFill>
-            <a:srgbClr val="1E2739"/>
-          </a:solidFill>
-          <a:ln w="12700">
+            <a:chOff x="4444898" y="2148840"/>
+            <a:chExt cx="3301898" cy="3200400"/>
+          </a:xfrm>
+        </p:grpSpPr>
+        <p:sp>
+          <p:nvSpPr>
+            <p:cNvPr id="11" name="Shape 7"/>
+            <p:cNvSpPr/>
+            <p:nvPr/>
+          </p:nvSpPr>
+          <p:spPr>
+            <a:xfrm>
+              <a:off x="4444898" y="2148840"/>
+              <a:ext cx="3301898" cy="3200400"/>
+            </a:xfrm>
+            <a:prstGeom prst="rect">
+              <a:avLst/>
+            </a:prstGeom>
             <a:solidFill>
-              <a:srgbClr val="2C3852"/>
+              <a:srgbClr val="1E2739"/>
             </a:solidFill>
-            <a:prstDash val="solid"/>
-          </a:ln>
-        </p:spPr>
-        <p:txBody>
-          <a:bodyPr/>
-          <a:lstStyle/>
-          <a:p>
-            <a:endParaRPr lang="en-CO"/>
-          </a:p>
-        </p:txBody>
-      </p:sp>
-      <p:sp>
-        <p:nvSpPr>
-          <p:cNvPr id="12" name="Text 8"/>
-          <p:cNvSpPr/>
-          <p:nvPr/>
-        </p:nvSpPr>
-        <p:spPr>
-          <a:xfrm>
-            <a:off x="4764938" y="2468880"/>
-            <a:ext cx="2661818" cy="320040"/>
-          </a:xfrm>
-          <a:prstGeom prst="rect">
-            <a:avLst/>
-          </a:prstGeom>
-          <a:noFill/>
-          <a:ln/>
-        </p:spPr>
-        <p:txBody>
-          <a:bodyPr wrap="square" lIns="0" tIns="0" rIns="0" bIns="0" rtlCol="0" anchor="ctr"/>
-          <a:lstStyle/>
-          <a:p>
-            <a:pPr marL="0" indent="0">
-              <a:buNone/>
-            </a:pPr>
-            <a:r>
-              <a:rPr lang="en-US" sz="1200" b="1" kern="0" spc="200" dirty="0">
-                <a:solidFill>
-                  <a:srgbClr val="9257F1"/>
-                </a:solidFill>
-                <a:latin typeface="Arial" pitchFamily="34" charset="0"/>
-                <a:ea typeface="Arial" pitchFamily="34" charset="-122"/>
-                <a:cs typeface="Arial" pitchFamily="34" charset="-120"/>
-              </a:rPr>
-              <a:t>QUIEN YA TRABAJA</a:t>
-            </a:r>
-            <a:endParaRPr lang="en-US" sz="1200" dirty="0"/>
-          </a:p>
-        </p:txBody>
-      </p:sp>
-      <p:sp>
-        <p:nvSpPr>
-          <p:cNvPr id="13" name="Text 9"/>
-          <p:cNvSpPr/>
-          <p:nvPr/>
-        </p:nvSpPr>
-        <p:spPr>
-          <a:xfrm>
-            <a:off x="4764938" y="2926080"/>
-            <a:ext cx="2661818" cy="2057400"/>
-          </a:xfrm>
-          <a:prstGeom prst="rect">
-            <a:avLst/>
-          </a:prstGeom>
-          <a:noFill/>
-          <a:ln/>
-        </p:spPr>
-        <p:txBody>
-          <a:bodyPr wrap="square" lIns="0" tIns="0" rIns="0" bIns="0" rtlCol="0" anchor="t"/>
-          <a:lstStyle/>
-          <a:p>
-            <a:pPr marL="0" indent="0">
-              <a:lnSpc>
-                <a:spcPts val="2600"/>
-              </a:lnSpc>
-              <a:buNone/>
-            </a:pPr>
-            <a:r>
-              <a:rPr lang="en-US" sz="2000" b="1" dirty="0">
-                <a:solidFill>
-                  <a:srgbClr val="FFFFFF"/>
-                </a:solidFill>
-                <a:latin typeface="Arial" pitchFamily="34" charset="0"/>
-                <a:ea typeface="Arial" pitchFamily="34" charset="-122"/>
-                <a:cs typeface="Arial" pitchFamily="34" charset="-120"/>
-              </a:rPr>
-              <a:t>¿Lo que sé hacer hoy seguirá siendo valioso dentro de cinco años?</a:t>
-            </a:r>
-            <a:endParaRPr lang="en-US" sz="2000" dirty="0"/>
-          </a:p>
-        </p:txBody>
-      </p:sp>
-      <p:sp>
-        <p:nvSpPr>
-          <p:cNvPr id="14" name="Shape 10"/>
-          <p:cNvSpPr/>
-          <p:nvPr/>
-        </p:nvSpPr>
-        <p:spPr>
+            <a:ln w="12700">
+              <a:solidFill>
+                <a:srgbClr val="2C3852"/>
+              </a:solidFill>
+              <a:prstDash val="solid"/>
+            </a:ln>
+          </p:spPr>
+          <p:txBody>
+            <a:bodyPr/>
+            <a:lstStyle/>
+            <a:p>
+              <a:endParaRPr lang="en-CO"/>
+            </a:p>
+          </p:txBody>
+        </p:sp>
+        <p:sp>
+          <p:nvSpPr>
+            <p:cNvPr id="12" name="Text 8"/>
+            <p:cNvSpPr/>
+            <p:nvPr/>
+          </p:nvSpPr>
+          <p:spPr>
+            <a:xfrm>
+              <a:off x="4764938" y="2468880"/>
+              <a:ext cx="2661818" cy="320040"/>
+            </a:xfrm>
+            <a:prstGeom prst="rect">
+              <a:avLst/>
+            </a:prstGeom>
+            <a:noFill/>
+            <a:ln/>
+          </p:spPr>
+          <p:txBody>
+            <a:bodyPr wrap="square" lIns="0" tIns="0" rIns="0" bIns="0" rtlCol="0" anchor="ctr"/>
+            <a:lstStyle/>
+            <a:p>
+              <a:pPr marL="0" indent="0">
+                <a:buNone/>
+              </a:pPr>
+              <a:r>
+                <a:rPr lang="en-US" sz="1200" b="1" kern="0" spc="200" dirty="0">
+                  <a:solidFill>
+                    <a:srgbClr val="9257F1"/>
+                  </a:solidFill>
+                  <a:latin typeface="Arial" pitchFamily="34" charset="0"/>
+                  <a:ea typeface="Arial" pitchFamily="34" charset="-122"/>
+                  <a:cs typeface="Arial" pitchFamily="34" charset="-120"/>
+                </a:rPr>
+                <a:t>QUIEN YA TRABAJA</a:t>
+              </a:r>
+              <a:endParaRPr lang="en-US" sz="1200" dirty="0"/>
+            </a:p>
+          </p:txBody>
+        </p:sp>
+        <p:sp>
+          <p:nvSpPr>
+            <p:cNvPr id="13" name="Text 9"/>
+            <p:cNvSpPr/>
+            <p:nvPr/>
+          </p:nvSpPr>
+          <p:spPr>
+            <a:xfrm>
+              <a:off x="4764938" y="2926080"/>
+              <a:ext cx="2661818" cy="2057400"/>
+            </a:xfrm>
+            <a:prstGeom prst="rect">
+              <a:avLst/>
+            </a:prstGeom>
+            <a:noFill/>
+            <a:ln/>
+          </p:spPr>
+          <p:txBody>
+            <a:bodyPr wrap="square" lIns="0" tIns="0" rIns="0" bIns="0" rtlCol="0" anchor="t"/>
+            <a:lstStyle/>
+            <a:p>
+              <a:pPr marL="0" indent="0">
+                <a:lnSpc>
+                  <a:spcPts val="2600"/>
+                </a:lnSpc>
+                <a:buNone/>
+              </a:pPr>
+              <a:r>
+                <a:rPr lang="en-US" sz="2000" b="1" dirty="0">
+                  <a:solidFill>
+                    <a:srgbClr val="FFFFFF"/>
+                  </a:solidFill>
+                  <a:latin typeface="Arial" pitchFamily="34" charset="0"/>
+                  <a:ea typeface="Arial" pitchFamily="34" charset="-122"/>
+                  <a:cs typeface="Arial" pitchFamily="34" charset="-120"/>
+                </a:rPr>
+                <a:t>¿Lo que sé hacer hoy seguirá siendo valioso dentro de cinco años?</a:t>
+              </a:r>
+              <a:endParaRPr lang="en-US" sz="2000" dirty="0"/>
+            </a:p>
+          </p:txBody>
+        </p:sp>
+      </p:grpSp>
+      <p:grpSp>
+        <p:nvGrpSpPr>
+          <p:cNvPr id="18" name="Group 17">
+            <a:extLst>
+              <a:ext uri="{FF2B5EF4-FFF2-40B4-BE49-F238E27FC236}">
+                <a16:creationId xmlns:a16="http://schemas.microsoft.com/office/drawing/2014/main" id="{93FFFAA0-3564-1ADB-57AA-090E99769698}"/>
+              </a:ext>
+            </a:extLst>
+          </p:cNvPr>
+          <p:cNvGrpSpPr/>
+          <p:nvPr/>
+        </p:nvGrpSpPr>
+        <p:grpSpPr>
           <a:xfrm>
             <a:off x="8066837" y="2148840"/>
             <a:ext cx="3301898" cy="3200400"/>
-          </a:xfrm>
-          <a:prstGeom prst="rect">
-            <a:avLst/>
-          </a:prstGeom>
-          <a:solidFill>
-            <a:srgbClr val="1E2739"/>
-          </a:solidFill>
-          <a:ln w="12700">
+            <a:chOff x="8066837" y="2148840"/>
+            <a:chExt cx="3301898" cy="3200400"/>
+          </a:xfrm>
+        </p:grpSpPr>
+        <p:sp>
+          <p:nvSpPr>
+            <p:cNvPr id="14" name="Shape 10"/>
+            <p:cNvSpPr/>
+            <p:nvPr/>
+          </p:nvSpPr>
+          <p:spPr>
+            <a:xfrm>
+              <a:off x="8066837" y="2148840"/>
+              <a:ext cx="3301898" cy="3200400"/>
+            </a:xfrm>
+            <a:prstGeom prst="rect">
+              <a:avLst/>
+            </a:prstGeom>
             <a:solidFill>
-              <a:srgbClr val="2C3852"/>
+              <a:srgbClr val="1E2739"/>
             </a:solidFill>
-            <a:prstDash val="solid"/>
-          </a:ln>
-        </p:spPr>
-        <p:txBody>
-          <a:bodyPr/>
-          <a:lstStyle/>
-          <a:p>
-            <a:endParaRPr lang="en-CO"/>
-          </a:p>
-        </p:txBody>
-      </p:sp>
-      <p:sp>
-        <p:nvSpPr>
-          <p:cNvPr id="15" name="Text 11"/>
-          <p:cNvSpPr/>
-          <p:nvPr/>
-        </p:nvSpPr>
-        <p:spPr>
-          <a:xfrm>
-            <a:off x="8386877" y="2468880"/>
-            <a:ext cx="2661818" cy="320040"/>
-          </a:xfrm>
-          <a:prstGeom prst="rect">
-            <a:avLst/>
-          </a:prstGeom>
-          <a:noFill/>
-          <a:ln/>
-        </p:spPr>
-        <p:txBody>
-          <a:bodyPr wrap="square" lIns="0" tIns="0" rIns="0" bIns="0" rtlCol="0" anchor="ctr"/>
-          <a:lstStyle/>
-          <a:p>
-            <a:pPr marL="0" indent="0">
-              <a:buNone/>
-            </a:pPr>
-            <a:r>
-              <a:rPr lang="en-US" sz="1200" b="1" kern="0" spc="200" dirty="0">
-                <a:solidFill>
-                  <a:srgbClr val="9257F1"/>
-                </a:solidFill>
-                <a:latin typeface="Arial" pitchFamily="34" charset="0"/>
-                <a:ea typeface="Arial" pitchFamily="34" charset="-122"/>
-                <a:cs typeface="Arial" pitchFamily="34" charset="-120"/>
-              </a:rPr>
-              <a:t>EMPRESAS</a:t>
-            </a:r>
-            <a:endParaRPr lang="en-US" sz="1200" dirty="0"/>
-          </a:p>
-        </p:txBody>
-      </p:sp>
-      <p:sp>
-        <p:nvSpPr>
-          <p:cNvPr id="16" name="Text 12"/>
-          <p:cNvSpPr/>
-          <p:nvPr/>
-        </p:nvSpPr>
-        <p:spPr>
-          <a:xfrm>
-            <a:off x="8386877" y="2926080"/>
-            <a:ext cx="2661818" cy="2057400"/>
-          </a:xfrm>
-          <a:prstGeom prst="rect">
-            <a:avLst/>
-          </a:prstGeom>
-          <a:noFill/>
-          <a:ln/>
-        </p:spPr>
-        <p:txBody>
-          <a:bodyPr wrap="square" lIns="0" tIns="0" rIns="0" bIns="0" rtlCol="0" anchor="t"/>
-          <a:lstStyle/>
-          <a:p>
-            <a:pPr marL="0" indent="0">
-              <a:lnSpc>
-                <a:spcPts val="2600"/>
-              </a:lnSpc>
-              <a:buNone/>
-            </a:pPr>
-            <a:r>
-              <a:rPr lang="en-US" sz="2000" b="1" dirty="0">
-                <a:solidFill>
-                  <a:srgbClr val="FFFFFF"/>
-                </a:solidFill>
-                <a:latin typeface="Arial" pitchFamily="34" charset="0"/>
-                <a:ea typeface="Arial" pitchFamily="34" charset="-122"/>
-                <a:cs typeface="Arial" pitchFamily="34" charset="-120"/>
-              </a:rPr>
-              <a:t>¿Qué debería esperar de un ingeniero que tiene IA disponible todo el tiempo?</a:t>
-            </a:r>
-            <a:endParaRPr lang="en-US" sz="2000" dirty="0"/>
-          </a:p>
-        </p:txBody>
-      </p:sp>
+            <a:ln w="12700">
+              <a:solidFill>
+                <a:srgbClr val="2C3852"/>
+              </a:solidFill>
+              <a:prstDash val="solid"/>
+            </a:ln>
+          </p:spPr>
+          <p:txBody>
+            <a:bodyPr/>
+            <a:lstStyle/>
+            <a:p>
+              <a:endParaRPr lang="en-CO"/>
+            </a:p>
+          </p:txBody>
+        </p:sp>
+        <p:sp>
+          <p:nvSpPr>
+            <p:cNvPr id="15" name="Text 11"/>
+            <p:cNvSpPr/>
+            <p:nvPr/>
+          </p:nvSpPr>
+          <p:spPr>
+            <a:xfrm>
+              <a:off x="8386877" y="2468880"/>
+              <a:ext cx="2661818" cy="320040"/>
+            </a:xfrm>
+            <a:prstGeom prst="rect">
+              <a:avLst/>
+            </a:prstGeom>
+            <a:noFill/>
+            <a:ln/>
+          </p:spPr>
+          <p:txBody>
+            <a:bodyPr wrap="square" lIns="0" tIns="0" rIns="0" bIns="0" rtlCol="0" anchor="ctr"/>
+            <a:lstStyle/>
+            <a:p>
+              <a:pPr marL="0" indent="0">
+                <a:buNone/>
+              </a:pPr>
+              <a:r>
+                <a:rPr lang="en-US" sz="1200" b="1" kern="0" spc="200" dirty="0">
+                  <a:solidFill>
+                    <a:srgbClr val="9257F1"/>
+                  </a:solidFill>
+                  <a:latin typeface="Arial" pitchFamily="34" charset="0"/>
+                  <a:ea typeface="Arial" pitchFamily="34" charset="-122"/>
+                  <a:cs typeface="Arial" pitchFamily="34" charset="-120"/>
+                </a:rPr>
+                <a:t>EMPRESAS</a:t>
+              </a:r>
+              <a:endParaRPr lang="en-US" sz="1200" dirty="0"/>
+            </a:p>
+          </p:txBody>
+        </p:sp>
+        <p:sp>
+          <p:nvSpPr>
+            <p:cNvPr id="16" name="Text 12"/>
+            <p:cNvSpPr/>
+            <p:nvPr/>
+          </p:nvSpPr>
+          <p:spPr>
+            <a:xfrm>
+              <a:off x="8386877" y="2926080"/>
+              <a:ext cx="2661818" cy="2057400"/>
+            </a:xfrm>
+            <a:prstGeom prst="rect">
+              <a:avLst/>
+            </a:prstGeom>
+            <a:noFill/>
+            <a:ln/>
+          </p:spPr>
+          <p:txBody>
+            <a:bodyPr wrap="square" lIns="0" tIns="0" rIns="0" bIns="0" rtlCol="0" anchor="t"/>
+            <a:lstStyle/>
+            <a:p>
+              <a:pPr marL="0" indent="0">
+                <a:lnSpc>
+                  <a:spcPts val="2600"/>
+                </a:lnSpc>
+                <a:buNone/>
+              </a:pPr>
+              <a:r>
+                <a:rPr lang="en-US" sz="2000" b="1" dirty="0">
+                  <a:solidFill>
+                    <a:srgbClr val="FFFFFF"/>
+                  </a:solidFill>
+                  <a:latin typeface="Arial" pitchFamily="34" charset="0"/>
+                  <a:ea typeface="Arial" pitchFamily="34" charset="-122"/>
+                  <a:cs typeface="Arial" pitchFamily="34" charset="-120"/>
+                </a:rPr>
+                <a:t>¿Qué debería esperar de un ingeniero que tiene IA disponible todo el tiempo?</a:t>
+              </a:r>
+              <a:endParaRPr lang="en-US" sz="2000" dirty="0"/>
+            </a:p>
+          </p:txBody>
+        </p:sp>
+      </p:grpSp>
     </p:spTree>
   </p:cSld>
   <p:clrMapOvr>
@@ -19777,396 +20309,501 @@
           </a:p>
         </p:txBody>
       </p:sp>
-      <p:sp>
-        <p:nvSpPr>
-          <p:cNvPr id="7" name="Text 3"/>
-          <p:cNvSpPr/>
-          <p:nvPr/>
-        </p:nvSpPr>
-        <p:spPr>
+      <p:grpSp>
+        <p:nvGrpSpPr>
+          <p:cNvPr id="2" name="Group 1">
+            <a:extLst>
+              <a:ext uri="{FF2B5EF4-FFF2-40B4-BE49-F238E27FC236}">
+                <a16:creationId xmlns:a16="http://schemas.microsoft.com/office/drawing/2014/main" id="{8BACF8E8-A2D5-6371-B6C5-82A748520B46}"/>
+              </a:ext>
+            </a:extLst>
+          </p:cNvPr>
+          <p:cNvGrpSpPr/>
+          <p:nvPr/>
+        </p:nvGrpSpPr>
+        <p:grpSpPr>
           <a:xfrm>
             <a:off x="822960" y="1371600"/>
-            <a:ext cx="640080" cy="640080"/>
-          </a:xfrm>
-          <a:prstGeom prst="rect">
-            <a:avLst/>
-          </a:prstGeom>
-          <a:noFill/>
-          <a:ln/>
-        </p:spPr>
-        <p:txBody>
-          <a:bodyPr wrap="square" lIns="0" tIns="0" rIns="0" bIns="0" rtlCol="0" anchor="ctr"/>
-          <a:lstStyle/>
-          <a:p>
-            <a:pPr marL="0" indent="0">
-              <a:buNone/>
-            </a:pPr>
-            <a:r>
-              <a:rPr lang="en-US" sz="3000" b="1" dirty="0">
-                <a:solidFill>
-                  <a:srgbClr val="9257F1"/>
-                </a:solidFill>
-                <a:latin typeface="Arial" pitchFamily="34" charset="0"/>
-                <a:ea typeface="Arial" pitchFamily="34" charset="-122"/>
-                <a:cs typeface="Arial" pitchFamily="34" charset="-120"/>
-              </a:rPr>
-              <a:t>1</a:t>
-            </a:r>
-            <a:endParaRPr lang="en-US" sz="3000" dirty="0"/>
-          </a:p>
-        </p:txBody>
-      </p:sp>
-      <p:sp>
-        <p:nvSpPr>
-          <p:cNvPr id="8" name="Text 4"/>
-          <p:cNvSpPr/>
-          <p:nvPr/>
-        </p:nvSpPr>
-        <p:spPr>
-          <a:xfrm>
-            <a:off x="1600200" y="1371600"/>
-            <a:ext cx="9631375" cy="640080"/>
-          </a:xfrm>
-          <a:prstGeom prst="rect">
-            <a:avLst/>
-          </a:prstGeom>
-          <a:noFill/>
-          <a:ln/>
-        </p:spPr>
-        <p:txBody>
-          <a:bodyPr wrap="square" lIns="0" tIns="0" rIns="0" bIns="0" rtlCol="0" anchor="ctr"/>
-          <a:lstStyle/>
-          <a:p>
-            <a:pPr marL="0" indent="0">
-              <a:buNone/>
-            </a:pPr>
-            <a:r>
-              <a:rPr lang="en-US" sz="2200" dirty="0">
-                <a:solidFill>
-                  <a:srgbClr val="FFFFFF"/>
-                </a:solidFill>
-                <a:latin typeface="Arial" pitchFamily="34" charset="0"/>
-                <a:ea typeface="Arial" pitchFamily="34" charset="-122"/>
-                <a:cs typeface="Arial" pitchFamily="34" charset="-120"/>
-              </a:rPr>
-              <a:t>¿Qué cambió realmente con la inteligencia artificial?</a:t>
-            </a:r>
-            <a:endParaRPr lang="en-US" sz="2200" dirty="0"/>
-          </a:p>
-        </p:txBody>
-      </p:sp>
-      <p:sp>
-        <p:nvSpPr>
-          <p:cNvPr id="9" name="Text 5"/>
-          <p:cNvSpPr/>
-          <p:nvPr/>
-        </p:nvSpPr>
-        <p:spPr>
+            <a:ext cx="10408615" cy="640080"/>
+            <a:chOff x="822960" y="1371600"/>
+            <a:chExt cx="10408615" cy="640080"/>
+          </a:xfrm>
+        </p:grpSpPr>
+        <p:sp>
+          <p:nvSpPr>
+            <p:cNvPr id="7" name="Text 3"/>
+            <p:cNvSpPr/>
+            <p:nvPr/>
+          </p:nvSpPr>
+          <p:spPr>
+            <a:xfrm>
+              <a:off x="822960" y="1371600"/>
+              <a:ext cx="640080" cy="640080"/>
+            </a:xfrm>
+            <a:prstGeom prst="rect">
+              <a:avLst/>
+            </a:prstGeom>
+            <a:noFill/>
+            <a:ln/>
+          </p:spPr>
+          <p:txBody>
+            <a:bodyPr wrap="square" lIns="0" tIns="0" rIns="0" bIns="0" rtlCol="0" anchor="ctr"/>
+            <a:lstStyle/>
+            <a:p>
+              <a:pPr marL="0" indent="0">
+                <a:buNone/>
+              </a:pPr>
+              <a:r>
+                <a:rPr lang="en-US" sz="3000" b="1" dirty="0">
+                  <a:solidFill>
+                    <a:srgbClr val="9257F1"/>
+                  </a:solidFill>
+                  <a:latin typeface="Arial" pitchFamily="34" charset="0"/>
+                  <a:ea typeface="Arial" pitchFamily="34" charset="-122"/>
+                  <a:cs typeface="Arial" pitchFamily="34" charset="-120"/>
+                </a:rPr>
+                <a:t>1</a:t>
+              </a:r>
+              <a:endParaRPr lang="en-US" sz="3000" dirty="0"/>
+            </a:p>
+          </p:txBody>
+        </p:sp>
+        <p:sp>
+          <p:nvSpPr>
+            <p:cNvPr id="8" name="Text 4"/>
+            <p:cNvSpPr/>
+            <p:nvPr/>
+          </p:nvSpPr>
+          <p:spPr>
+            <a:xfrm>
+              <a:off x="1600200" y="1371600"/>
+              <a:ext cx="9631375" cy="640080"/>
+            </a:xfrm>
+            <a:prstGeom prst="rect">
+              <a:avLst/>
+            </a:prstGeom>
+            <a:noFill/>
+            <a:ln/>
+          </p:spPr>
+          <p:txBody>
+            <a:bodyPr wrap="square" lIns="0" tIns="0" rIns="0" bIns="0" rtlCol="0" anchor="ctr"/>
+            <a:lstStyle/>
+            <a:p>
+              <a:pPr marL="0" indent="0">
+                <a:buNone/>
+              </a:pPr>
+              <a:r>
+                <a:rPr lang="en-US" sz="2200" dirty="0">
+                  <a:solidFill>
+                    <a:srgbClr val="FFFFFF"/>
+                  </a:solidFill>
+                  <a:latin typeface="Arial" pitchFamily="34" charset="0"/>
+                  <a:ea typeface="Arial" pitchFamily="34" charset="-122"/>
+                  <a:cs typeface="Arial" pitchFamily="34" charset="-120"/>
+                </a:rPr>
+                <a:t>¿Qué cambió realmente con la inteligencia artificial?</a:t>
+              </a:r>
+              <a:endParaRPr lang="en-US" sz="2200" dirty="0"/>
+            </a:p>
+          </p:txBody>
+        </p:sp>
+      </p:grpSp>
+      <p:grpSp>
+        <p:nvGrpSpPr>
+          <p:cNvPr id="17" name="Group 16">
+            <a:extLst>
+              <a:ext uri="{FF2B5EF4-FFF2-40B4-BE49-F238E27FC236}">
+                <a16:creationId xmlns:a16="http://schemas.microsoft.com/office/drawing/2014/main" id="{9B39826F-573B-1CFC-2459-25A321F03D90}"/>
+              </a:ext>
+            </a:extLst>
+          </p:cNvPr>
+          <p:cNvGrpSpPr/>
+          <p:nvPr/>
+        </p:nvGrpSpPr>
+        <p:grpSpPr>
           <a:xfrm>
             <a:off x="822960" y="2286000"/>
-            <a:ext cx="640080" cy="640080"/>
-          </a:xfrm>
-          <a:prstGeom prst="rect">
-            <a:avLst/>
-          </a:prstGeom>
-          <a:noFill/>
-          <a:ln/>
-        </p:spPr>
-        <p:txBody>
-          <a:bodyPr wrap="square" lIns="0" tIns="0" rIns="0" bIns="0" rtlCol="0" anchor="ctr"/>
-          <a:lstStyle/>
-          <a:p>
-            <a:pPr marL="0" indent="0">
-              <a:buNone/>
-            </a:pPr>
-            <a:r>
-              <a:rPr lang="en-US" sz="3000" b="1" dirty="0">
-                <a:solidFill>
-                  <a:srgbClr val="9257F1"/>
-                </a:solidFill>
-                <a:latin typeface="Arial" pitchFamily="34" charset="0"/>
-                <a:ea typeface="Arial" pitchFamily="34" charset="-122"/>
-                <a:cs typeface="Arial" pitchFamily="34" charset="-120"/>
-              </a:rPr>
-              <a:t>2</a:t>
-            </a:r>
-            <a:endParaRPr lang="en-US" sz="3000" dirty="0"/>
-          </a:p>
-        </p:txBody>
-      </p:sp>
-      <p:sp>
-        <p:nvSpPr>
-          <p:cNvPr id="10" name="Text 6"/>
-          <p:cNvSpPr/>
-          <p:nvPr/>
-        </p:nvSpPr>
-        <p:spPr>
-          <a:xfrm>
-            <a:off x="1600200" y="2286000"/>
-            <a:ext cx="9631375" cy="640080"/>
-          </a:xfrm>
-          <a:prstGeom prst="rect">
-            <a:avLst/>
-          </a:prstGeom>
-          <a:noFill/>
-          <a:ln/>
-        </p:spPr>
-        <p:txBody>
-          <a:bodyPr wrap="square" lIns="0" tIns="0" rIns="0" bIns="0" rtlCol="0" anchor="ctr"/>
-          <a:lstStyle/>
-          <a:p>
-            <a:pPr marL="0" indent="0">
-              <a:buNone/>
-            </a:pPr>
-            <a:r>
-              <a:rPr lang="en-US" sz="2200" dirty="0">
-                <a:solidFill>
-                  <a:srgbClr val="FFFFFF"/>
-                </a:solidFill>
-                <a:latin typeface="Arial" pitchFamily="34" charset="0"/>
-                <a:ea typeface="Arial" pitchFamily="34" charset="-122"/>
-                <a:cs typeface="Arial" pitchFamily="34" charset="-120"/>
-              </a:rPr>
-              <a:t>¿Se va a acabar el trabajo para los programadores?</a:t>
-            </a:r>
-            <a:endParaRPr lang="en-US" sz="2200" dirty="0"/>
-          </a:p>
-        </p:txBody>
-      </p:sp>
-      <p:sp>
-        <p:nvSpPr>
-          <p:cNvPr id="11" name="Text 7"/>
-          <p:cNvSpPr/>
-          <p:nvPr/>
-        </p:nvSpPr>
-        <p:spPr>
+            <a:ext cx="10408615" cy="640080"/>
+            <a:chOff x="822960" y="2286000"/>
+            <a:chExt cx="10408615" cy="640080"/>
+          </a:xfrm>
+        </p:grpSpPr>
+        <p:sp>
+          <p:nvSpPr>
+            <p:cNvPr id="9" name="Text 5"/>
+            <p:cNvSpPr/>
+            <p:nvPr/>
+          </p:nvSpPr>
+          <p:spPr>
+            <a:xfrm>
+              <a:off x="822960" y="2286000"/>
+              <a:ext cx="640080" cy="640080"/>
+            </a:xfrm>
+            <a:prstGeom prst="rect">
+              <a:avLst/>
+            </a:prstGeom>
+            <a:noFill/>
+            <a:ln/>
+          </p:spPr>
+          <p:txBody>
+            <a:bodyPr wrap="square" lIns="0" tIns="0" rIns="0" bIns="0" rtlCol="0" anchor="ctr"/>
+            <a:lstStyle/>
+            <a:p>
+              <a:pPr marL="0" indent="0">
+                <a:buNone/>
+              </a:pPr>
+              <a:r>
+                <a:rPr lang="en-US" sz="3000" b="1" dirty="0">
+                  <a:solidFill>
+                    <a:srgbClr val="9257F1"/>
+                  </a:solidFill>
+                  <a:latin typeface="Arial" pitchFamily="34" charset="0"/>
+                  <a:ea typeface="Arial" pitchFamily="34" charset="-122"/>
+                  <a:cs typeface="Arial" pitchFamily="34" charset="-120"/>
+                </a:rPr>
+                <a:t>2</a:t>
+              </a:r>
+              <a:endParaRPr lang="en-US" sz="3000" dirty="0"/>
+            </a:p>
+          </p:txBody>
+        </p:sp>
+        <p:sp>
+          <p:nvSpPr>
+            <p:cNvPr id="10" name="Text 6"/>
+            <p:cNvSpPr/>
+            <p:nvPr/>
+          </p:nvSpPr>
+          <p:spPr>
+            <a:xfrm>
+              <a:off x="1600200" y="2286000"/>
+              <a:ext cx="9631375" cy="640080"/>
+            </a:xfrm>
+            <a:prstGeom prst="rect">
+              <a:avLst/>
+            </a:prstGeom>
+            <a:noFill/>
+            <a:ln/>
+          </p:spPr>
+          <p:txBody>
+            <a:bodyPr wrap="square" lIns="0" tIns="0" rIns="0" bIns="0" rtlCol="0" anchor="ctr"/>
+            <a:lstStyle/>
+            <a:p>
+              <a:pPr marL="0" indent="0">
+                <a:buNone/>
+              </a:pPr>
+              <a:r>
+                <a:rPr lang="en-US" sz="2200" dirty="0">
+                  <a:solidFill>
+                    <a:srgbClr val="FFFFFF"/>
+                  </a:solidFill>
+                  <a:latin typeface="Arial" pitchFamily="34" charset="0"/>
+                  <a:ea typeface="Arial" pitchFamily="34" charset="-122"/>
+                  <a:cs typeface="Arial" pitchFamily="34" charset="-120"/>
+                </a:rPr>
+                <a:t>¿Se va a acabar el trabajo para los programadores?</a:t>
+              </a:r>
+              <a:endParaRPr lang="en-US" sz="2200" dirty="0"/>
+            </a:p>
+          </p:txBody>
+        </p:sp>
+      </p:grpSp>
+      <p:grpSp>
+        <p:nvGrpSpPr>
+          <p:cNvPr id="18" name="Group 17">
+            <a:extLst>
+              <a:ext uri="{FF2B5EF4-FFF2-40B4-BE49-F238E27FC236}">
+                <a16:creationId xmlns:a16="http://schemas.microsoft.com/office/drawing/2014/main" id="{B0618DC1-24BD-D7E5-8C28-6C62D4CCACF5}"/>
+              </a:ext>
+            </a:extLst>
+          </p:cNvPr>
+          <p:cNvGrpSpPr/>
+          <p:nvPr/>
+        </p:nvGrpSpPr>
+        <p:grpSpPr>
           <a:xfrm>
             <a:off x="822960" y="3200400"/>
-            <a:ext cx="640080" cy="640080"/>
-          </a:xfrm>
-          <a:prstGeom prst="rect">
-            <a:avLst/>
-          </a:prstGeom>
-          <a:noFill/>
-          <a:ln/>
-        </p:spPr>
-        <p:txBody>
-          <a:bodyPr wrap="square" lIns="0" tIns="0" rIns="0" bIns="0" rtlCol="0" anchor="ctr"/>
-          <a:lstStyle/>
-          <a:p>
-            <a:pPr marL="0" indent="0">
-              <a:buNone/>
-            </a:pPr>
-            <a:r>
-              <a:rPr lang="en-US" sz="3000" b="1" dirty="0">
-                <a:solidFill>
-                  <a:srgbClr val="9257F1"/>
-                </a:solidFill>
-                <a:latin typeface="Arial" pitchFamily="34" charset="0"/>
-                <a:ea typeface="Arial" pitchFamily="34" charset="-122"/>
-                <a:cs typeface="Arial" pitchFamily="34" charset="-120"/>
-              </a:rPr>
-              <a:t>3</a:t>
-            </a:r>
-            <a:endParaRPr lang="en-US" sz="3000" dirty="0"/>
-          </a:p>
-        </p:txBody>
-      </p:sp>
-      <p:sp>
-        <p:nvSpPr>
-          <p:cNvPr id="12" name="Text 8"/>
-          <p:cNvSpPr/>
-          <p:nvPr/>
-        </p:nvSpPr>
-        <p:spPr>
-          <a:xfrm>
-            <a:off x="1600200" y="3200400"/>
-            <a:ext cx="9631375" cy="640080"/>
-          </a:xfrm>
-          <a:prstGeom prst="rect">
-            <a:avLst/>
-          </a:prstGeom>
-          <a:noFill/>
-          <a:ln/>
-        </p:spPr>
-        <p:txBody>
-          <a:bodyPr wrap="square" lIns="0" tIns="0" rIns="0" bIns="0" rtlCol="0" anchor="ctr"/>
-          <a:lstStyle/>
-          <a:p>
-            <a:pPr marL="0" indent="0">
-              <a:buNone/>
-            </a:pPr>
-            <a:r>
-              <a:rPr lang="en-US" sz="2200" dirty="0">
-                <a:solidFill>
-                  <a:srgbClr val="FFFFFF"/>
-                </a:solidFill>
-                <a:latin typeface="Arial" pitchFamily="34" charset="0"/>
-                <a:ea typeface="Arial" pitchFamily="34" charset="-122"/>
-                <a:cs typeface="Arial" pitchFamily="34" charset="-120"/>
-              </a:rPr>
-              <a:t>¿Qué pasa cuando la IA escribe software que no entendemos?</a:t>
-            </a:r>
-            <a:endParaRPr lang="en-US" sz="2200" dirty="0"/>
-          </a:p>
-        </p:txBody>
-      </p:sp>
-      <p:sp>
-        <p:nvSpPr>
-          <p:cNvPr id="13" name="Text 9"/>
-          <p:cNvSpPr/>
-          <p:nvPr/>
-        </p:nvSpPr>
-        <p:spPr>
+            <a:ext cx="10408615" cy="640080"/>
+            <a:chOff x="822960" y="3200400"/>
+            <a:chExt cx="10408615" cy="640080"/>
+          </a:xfrm>
+        </p:grpSpPr>
+        <p:sp>
+          <p:nvSpPr>
+            <p:cNvPr id="11" name="Text 7"/>
+            <p:cNvSpPr/>
+            <p:nvPr/>
+          </p:nvSpPr>
+          <p:spPr>
+            <a:xfrm>
+              <a:off x="822960" y="3200400"/>
+              <a:ext cx="640080" cy="640080"/>
+            </a:xfrm>
+            <a:prstGeom prst="rect">
+              <a:avLst/>
+            </a:prstGeom>
+            <a:noFill/>
+            <a:ln/>
+          </p:spPr>
+          <p:txBody>
+            <a:bodyPr wrap="square" lIns="0" tIns="0" rIns="0" bIns="0" rtlCol="0" anchor="ctr"/>
+            <a:lstStyle/>
+            <a:p>
+              <a:pPr marL="0" indent="0">
+                <a:buNone/>
+              </a:pPr>
+              <a:r>
+                <a:rPr lang="en-US" sz="3000" b="1" dirty="0">
+                  <a:solidFill>
+                    <a:srgbClr val="9257F1"/>
+                  </a:solidFill>
+                  <a:latin typeface="Arial" pitchFamily="34" charset="0"/>
+                  <a:ea typeface="Arial" pitchFamily="34" charset="-122"/>
+                  <a:cs typeface="Arial" pitchFamily="34" charset="-120"/>
+                </a:rPr>
+                <a:t>3</a:t>
+              </a:r>
+              <a:endParaRPr lang="en-US" sz="3000" dirty="0"/>
+            </a:p>
+          </p:txBody>
+        </p:sp>
+        <p:sp>
+          <p:nvSpPr>
+            <p:cNvPr id="12" name="Text 8"/>
+            <p:cNvSpPr/>
+            <p:nvPr/>
+          </p:nvSpPr>
+          <p:spPr>
+            <a:xfrm>
+              <a:off x="1600200" y="3200400"/>
+              <a:ext cx="9631375" cy="640080"/>
+            </a:xfrm>
+            <a:prstGeom prst="rect">
+              <a:avLst/>
+            </a:prstGeom>
+            <a:noFill/>
+            <a:ln/>
+          </p:spPr>
+          <p:txBody>
+            <a:bodyPr wrap="square" lIns="0" tIns="0" rIns="0" bIns="0" rtlCol="0" anchor="ctr"/>
+            <a:lstStyle/>
+            <a:p>
+              <a:pPr marL="0" indent="0">
+                <a:buNone/>
+              </a:pPr>
+              <a:r>
+                <a:rPr lang="en-US" sz="2200" dirty="0">
+                  <a:solidFill>
+                    <a:srgbClr val="FFFFFF"/>
+                  </a:solidFill>
+                  <a:latin typeface="Arial" pitchFamily="34" charset="0"/>
+                  <a:ea typeface="Arial" pitchFamily="34" charset="-122"/>
+                  <a:cs typeface="Arial" pitchFamily="34" charset="-120"/>
+                </a:rPr>
+                <a:t>¿Qué pasa cuando la IA escribe software que no entendemos?</a:t>
+              </a:r>
+              <a:endParaRPr lang="en-US" sz="2200" dirty="0"/>
+            </a:p>
+          </p:txBody>
+        </p:sp>
+      </p:grpSp>
+      <p:grpSp>
+        <p:nvGrpSpPr>
+          <p:cNvPr id="19" name="Group 18">
+            <a:extLst>
+              <a:ext uri="{FF2B5EF4-FFF2-40B4-BE49-F238E27FC236}">
+                <a16:creationId xmlns:a16="http://schemas.microsoft.com/office/drawing/2014/main" id="{DD29F4C2-026A-A62B-49F7-348755B6EA2A}"/>
+              </a:ext>
+            </a:extLst>
+          </p:cNvPr>
+          <p:cNvGrpSpPr/>
+          <p:nvPr/>
+        </p:nvGrpSpPr>
+        <p:grpSpPr>
           <a:xfrm>
             <a:off x="822960" y="4114800"/>
-            <a:ext cx="640080" cy="640080"/>
-          </a:xfrm>
-          <a:prstGeom prst="rect">
-            <a:avLst/>
-          </a:prstGeom>
-          <a:noFill/>
-          <a:ln/>
-        </p:spPr>
-        <p:txBody>
-          <a:bodyPr wrap="square" lIns="0" tIns="0" rIns="0" bIns="0" rtlCol="0" anchor="ctr"/>
-          <a:lstStyle/>
-          <a:p>
-            <a:pPr marL="0" indent="0">
-              <a:buNone/>
-            </a:pPr>
-            <a:r>
-              <a:rPr lang="en-US" sz="3000" b="1" dirty="0">
-                <a:solidFill>
-                  <a:srgbClr val="9257F1"/>
-                </a:solidFill>
-                <a:latin typeface="Arial" pitchFamily="34" charset="0"/>
-                <a:ea typeface="Arial" pitchFamily="34" charset="-122"/>
-                <a:cs typeface="Arial" pitchFamily="34" charset="-120"/>
-              </a:rPr>
-              <a:t>4</a:t>
-            </a:r>
-            <a:endParaRPr lang="en-US" sz="3000" dirty="0"/>
-          </a:p>
-        </p:txBody>
-      </p:sp>
-      <p:sp>
-        <p:nvSpPr>
-          <p:cNvPr id="14" name="Text 10"/>
-          <p:cNvSpPr/>
-          <p:nvPr/>
-        </p:nvSpPr>
-        <p:spPr>
-          <a:xfrm>
-            <a:off x="1600200" y="4114800"/>
-            <a:ext cx="9631375" cy="640080"/>
-          </a:xfrm>
-          <a:prstGeom prst="rect">
-            <a:avLst/>
-          </a:prstGeom>
-          <a:noFill/>
-          <a:ln/>
-        </p:spPr>
-        <p:txBody>
-          <a:bodyPr wrap="square" lIns="0" tIns="0" rIns="0" bIns="0" rtlCol="0" anchor="ctr"/>
-          <a:lstStyle/>
-          <a:p>
-            <a:pPr marL="0" indent="0">
-              <a:buNone/>
-            </a:pPr>
-            <a:r>
-              <a:rPr lang="en-US" sz="2200" dirty="0">
-                <a:solidFill>
-                  <a:srgbClr val="FFFFFF"/>
-                </a:solidFill>
-                <a:latin typeface="Arial" pitchFamily="34" charset="0"/>
-                <a:ea typeface="Arial" pitchFamily="34" charset="-122"/>
-                <a:cs typeface="Arial" pitchFamily="34" charset="-120"/>
-              </a:rPr>
-              <a:t>¿Vale la pena aprender a programar?</a:t>
-            </a:r>
-            <a:endParaRPr lang="en-US" sz="2200" dirty="0"/>
-          </a:p>
-        </p:txBody>
-      </p:sp>
-      <p:sp>
-        <p:nvSpPr>
-          <p:cNvPr id="15" name="Text 11"/>
-          <p:cNvSpPr/>
-          <p:nvPr/>
-        </p:nvSpPr>
-        <p:spPr>
+            <a:ext cx="10408615" cy="640080"/>
+            <a:chOff x="822960" y="4114800"/>
+            <a:chExt cx="10408615" cy="640080"/>
+          </a:xfrm>
+        </p:grpSpPr>
+        <p:sp>
+          <p:nvSpPr>
+            <p:cNvPr id="13" name="Text 9"/>
+            <p:cNvSpPr/>
+            <p:nvPr/>
+          </p:nvSpPr>
+          <p:spPr>
+            <a:xfrm>
+              <a:off x="822960" y="4114800"/>
+              <a:ext cx="640080" cy="640080"/>
+            </a:xfrm>
+            <a:prstGeom prst="rect">
+              <a:avLst/>
+            </a:prstGeom>
+            <a:noFill/>
+            <a:ln/>
+          </p:spPr>
+          <p:txBody>
+            <a:bodyPr wrap="square" lIns="0" tIns="0" rIns="0" bIns="0" rtlCol="0" anchor="ctr"/>
+            <a:lstStyle/>
+            <a:p>
+              <a:pPr marL="0" indent="0">
+                <a:buNone/>
+              </a:pPr>
+              <a:r>
+                <a:rPr lang="en-US" sz="3000" b="1" dirty="0">
+                  <a:solidFill>
+                    <a:srgbClr val="9257F1"/>
+                  </a:solidFill>
+                  <a:latin typeface="Arial" pitchFamily="34" charset="0"/>
+                  <a:ea typeface="Arial" pitchFamily="34" charset="-122"/>
+                  <a:cs typeface="Arial" pitchFamily="34" charset="-120"/>
+                </a:rPr>
+                <a:t>4</a:t>
+              </a:r>
+              <a:endParaRPr lang="en-US" sz="3000" dirty="0"/>
+            </a:p>
+          </p:txBody>
+        </p:sp>
+        <p:sp>
+          <p:nvSpPr>
+            <p:cNvPr id="14" name="Text 10"/>
+            <p:cNvSpPr/>
+            <p:nvPr/>
+          </p:nvSpPr>
+          <p:spPr>
+            <a:xfrm>
+              <a:off x="1600200" y="4114800"/>
+              <a:ext cx="9631375" cy="640080"/>
+            </a:xfrm>
+            <a:prstGeom prst="rect">
+              <a:avLst/>
+            </a:prstGeom>
+            <a:noFill/>
+            <a:ln/>
+          </p:spPr>
+          <p:txBody>
+            <a:bodyPr wrap="square" lIns="0" tIns="0" rIns="0" bIns="0" rtlCol="0" anchor="ctr"/>
+            <a:lstStyle/>
+            <a:p>
+              <a:pPr marL="0" indent="0">
+                <a:buNone/>
+              </a:pPr>
+              <a:r>
+                <a:rPr lang="en-US" sz="2200" dirty="0">
+                  <a:solidFill>
+                    <a:srgbClr val="FFFFFF"/>
+                  </a:solidFill>
+                  <a:latin typeface="Arial" pitchFamily="34" charset="0"/>
+                  <a:ea typeface="Arial" pitchFamily="34" charset="-122"/>
+                  <a:cs typeface="Arial" pitchFamily="34" charset="-120"/>
+                </a:rPr>
+                <a:t>¿Vale la pena aprender a programar?</a:t>
+              </a:r>
+              <a:endParaRPr lang="en-US" sz="2200" dirty="0"/>
+            </a:p>
+          </p:txBody>
+        </p:sp>
+      </p:grpSp>
+      <p:grpSp>
+        <p:nvGrpSpPr>
+          <p:cNvPr id="20" name="Group 19">
+            <a:extLst>
+              <a:ext uri="{FF2B5EF4-FFF2-40B4-BE49-F238E27FC236}">
+                <a16:creationId xmlns:a16="http://schemas.microsoft.com/office/drawing/2014/main" id="{6327B06F-7009-3B4C-AA40-54D04DCDA2B5}"/>
+              </a:ext>
+            </a:extLst>
+          </p:cNvPr>
+          <p:cNvGrpSpPr/>
+          <p:nvPr/>
+        </p:nvGrpSpPr>
+        <p:grpSpPr>
           <a:xfrm>
             <a:off x="822960" y="5029200"/>
-            <a:ext cx="640080" cy="640080"/>
-          </a:xfrm>
-          <a:prstGeom prst="rect">
-            <a:avLst/>
-          </a:prstGeom>
-          <a:noFill/>
-          <a:ln/>
-        </p:spPr>
-        <p:txBody>
-          <a:bodyPr wrap="square" lIns="0" tIns="0" rIns="0" bIns="0" rtlCol="0" anchor="ctr"/>
-          <a:lstStyle/>
-          <a:p>
-            <a:pPr marL="0" indent="0">
-              <a:buNone/>
-            </a:pPr>
-            <a:r>
-              <a:rPr lang="en-US" sz="3000" b="1" dirty="0">
-                <a:solidFill>
-                  <a:srgbClr val="9257F1"/>
-                </a:solidFill>
-                <a:latin typeface="Arial" pitchFamily="34" charset="0"/>
-                <a:ea typeface="Arial" pitchFamily="34" charset="-122"/>
-                <a:cs typeface="Arial" pitchFamily="34" charset="-120"/>
-              </a:rPr>
-              <a:t>5</a:t>
-            </a:r>
-            <a:endParaRPr lang="en-US" sz="3000" dirty="0"/>
-          </a:p>
-        </p:txBody>
-      </p:sp>
-      <p:sp>
-        <p:nvSpPr>
-          <p:cNvPr id="16" name="Text 12"/>
-          <p:cNvSpPr/>
-          <p:nvPr/>
-        </p:nvSpPr>
-        <p:spPr>
-          <a:xfrm>
-            <a:off x="1600200" y="5029200"/>
-            <a:ext cx="9631375" cy="640080"/>
-          </a:xfrm>
-          <a:prstGeom prst="rect">
-            <a:avLst/>
-          </a:prstGeom>
-          <a:noFill/>
-          <a:ln/>
-        </p:spPr>
-        <p:txBody>
-          <a:bodyPr wrap="square" lIns="0" tIns="0" rIns="0" bIns="0" rtlCol="0" anchor="ctr"/>
-          <a:lstStyle/>
-          <a:p>
-            <a:pPr marL="0" indent="0">
-              <a:buNone/>
-            </a:pPr>
-            <a:r>
-              <a:rPr lang="en-US" sz="2200" dirty="0">
-                <a:solidFill>
-                  <a:srgbClr val="FFFFFF"/>
-                </a:solidFill>
-                <a:latin typeface="Arial" pitchFamily="34" charset="0"/>
-                <a:ea typeface="Arial" pitchFamily="34" charset="-122"/>
-                <a:cs typeface="Arial" pitchFamily="34" charset="-120"/>
-              </a:rPr>
-              <a:t>¿Qué deberíamos aprender ahora?</a:t>
-            </a:r>
-            <a:endParaRPr lang="en-US" sz="2200" dirty="0"/>
-          </a:p>
-        </p:txBody>
-      </p:sp>
+            <a:ext cx="10408615" cy="640080"/>
+            <a:chOff x="822960" y="5029200"/>
+            <a:chExt cx="10408615" cy="640080"/>
+          </a:xfrm>
+        </p:grpSpPr>
+        <p:sp>
+          <p:nvSpPr>
+            <p:cNvPr id="15" name="Text 11"/>
+            <p:cNvSpPr/>
+            <p:nvPr/>
+          </p:nvSpPr>
+          <p:spPr>
+            <a:xfrm>
+              <a:off x="822960" y="5029200"/>
+              <a:ext cx="640080" cy="640080"/>
+            </a:xfrm>
+            <a:prstGeom prst="rect">
+              <a:avLst/>
+            </a:prstGeom>
+            <a:noFill/>
+            <a:ln/>
+          </p:spPr>
+          <p:txBody>
+            <a:bodyPr wrap="square" lIns="0" tIns="0" rIns="0" bIns="0" rtlCol="0" anchor="ctr"/>
+            <a:lstStyle/>
+            <a:p>
+              <a:pPr marL="0" indent="0">
+                <a:buNone/>
+              </a:pPr>
+              <a:r>
+                <a:rPr lang="en-US" sz="3000" b="1" dirty="0">
+                  <a:solidFill>
+                    <a:srgbClr val="9257F1"/>
+                  </a:solidFill>
+                  <a:latin typeface="Arial" pitchFamily="34" charset="0"/>
+                  <a:ea typeface="Arial" pitchFamily="34" charset="-122"/>
+                  <a:cs typeface="Arial" pitchFamily="34" charset="-120"/>
+                </a:rPr>
+                <a:t>5</a:t>
+              </a:r>
+              <a:endParaRPr lang="en-US" sz="3000" dirty="0"/>
+            </a:p>
+          </p:txBody>
+        </p:sp>
+        <p:sp>
+          <p:nvSpPr>
+            <p:cNvPr id="16" name="Text 12"/>
+            <p:cNvSpPr/>
+            <p:nvPr/>
+          </p:nvSpPr>
+          <p:spPr>
+            <a:xfrm>
+              <a:off x="1600200" y="5029200"/>
+              <a:ext cx="9631375" cy="640080"/>
+            </a:xfrm>
+            <a:prstGeom prst="rect">
+              <a:avLst/>
+            </a:prstGeom>
+            <a:noFill/>
+            <a:ln/>
+          </p:spPr>
+          <p:txBody>
+            <a:bodyPr wrap="square" lIns="0" tIns="0" rIns="0" bIns="0" rtlCol="0" anchor="ctr"/>
+            <a:lstStyle/>
+            <a:p>
+              <a:pPr marL="0" indent="0">
+                <a:buNone/>
+              </a:pPr>
+              <a:r>
+                <a:rPr lang="en-US" sz="2200" dirty="0">
+                  <a:solidFill>
+                    <a:srgbClr val="FFFFFF"/>
+                  </a:solidFill>
+                  <a:latin typeface="Arial" pitchFamily="34" charset="0"/>
+                  <a:ea typeface="Arial" pitchFamily="34" charset="-122"/>
+                  <a:cs typeface="Arial" pitchFamily="34" charset="-120"/>
+                </a:rPr>
+                <a:t>¿Qué deberíamos aprender ahora?</a:t>
+              </a:r>
+              <a:endParaRPr lang="en-US" sz="2200" dirty="0"/>
+            </a:p>
+          </p:txBody>
+        </p:sp>
+      </p:grpSp>
     </p:spTree>
   </p:cSld>
   <p:clrMapOvr>

</xml_diff>

<commit_message>
Agregados QRs al final
</commit_message>
<xml_diff>
--- a/Slides_IA_AWS_UG_Cucuta.pptx
+++ b/Slides_IA_AWS_UG_Cucuta.pptx
@@ -15519,7 +15519,7 @@
         </p:nvSpPr>
         <p:spPr>
           <a:xfrm>
-            <a:off x="822960" y="4069080"/>
+            <a:off x="548640" y="4087368"/>
             <a:ext cx="2606040" cy="1417320"/>
           </a:xfrm>
           <a:prstGeom prst="rect">
@@ -15551,7 +15551,7 @@
         </p:nvSpPr>
         <p:spPr>
           <a:xfrm>
-            <a:off x="1024128" y="4233672"/>
+            <a:off x="749808" y="4251960"/>
             <a:ext cx="2203704" cy="457200"/>
           </a:xfrm>
           <a:prstGeom prst="rect">
@@ -15590,7 +15590,7 @@
         </p:nvSpPr>
         <p:spPr>
           <a:xfrm>
-            <a:off x="1024128" y="4727448"/>
+            <a:off x="749808" y="4745736"/>
             <a:ext cx="2203704" cy="594360"/>
           </a:xfrm>
           <a:prstGeom prst="rect">
@@ -15672,7 +15672,7 @@
         </p:nvSpPr>
         <p:spPr>
           <a:xfrm>
-            <a:off x="3685032" y="3538728"/>
+            <a:off x="3410712" y="3557016"/>
             <a:ext cx="2606040" cy="1947672"/>
           </a:xfrm>
           <a:prstGeom prst="rect">
@@ -15704,7 +15704,7 @@
         </p:nvSpPr>
         <p:spPr>
           <a:xfrm>
-            <a:off x="3886200" y="3703320"/>
+            <a:off x="3611880" y="3721608"/>
             <a:ext cx="2203704" cy="457200"/>
           </a:xfrm>
           <a:prstGeom prst="rect">
@@ -15743,7 +15743,7 @@
         </p:nvSpPr>
         <p:spPr>
           <a:xfrm>
-            <a:off x="3886200" y="4197096"/>
+            <a:off x="3611880" y="4215384"/>
             <a:ext cx="2203704" cy="1124712"/>
           </a:xfrm>
           <a:prstGeom prst="rect">
@@ -15825,7 +15825,7 @@
         </p:nvSpPr>
         <p:spPr>
           <a:xfrm>
-            <a:off x="6547104" y="3008376"/>
+            <a:off x="6272784" y="3026664"/>
             <a:ext cx="2606040" cy="2478024"/>
           </a:xfrm>
           <a:prstGeom prst="rect">
@@ -15857,7 +15857,7 @@
         </p:nvSpPr>
         <p:spPr>
           <a:xfrm>
-            <a:off x="6748272" y="3172968"/>
+            <a:off x="6473952" y="3191256"/>
             <a:ext cx="2203704" cy="457200"/>
           </a:xfrm>
           <a:prstGeom prst="rect">
@@ -15896,7 +15896,7 @@
         </p:nvSpPr>
         <p:spPr>
           <a:xfrm>
-            <a:off x="6748272" y="3666744"/>
+            <a:off x="6473952" y="3685032"/>
             <a:ext cx="2203704" cy="1655064"/>
           </a:xfrm>
           <a:prstGeom prst="rect">
@@ -15978,7 +15978,7 @@
         </p:nvSpPr>
         <p:spPr>
           <a:xfrm>
-            <a:off x="9409176" y="2478024"/>
+            <a:off x="9134856" y="2496312"/>
             <a:ext cx="2606040" cy="3008376"/>
           </a:xfrm>
           <a:prstGeom prst="rect">
@@ -16010,7 +16010,7 @@
         </p:nvSpPr>
         <p:spPr>
           <a:xfrm>
-            <a:off x="9610344" y="2642616"/>
+            <a:off x="9336024" y="2660904"/>
             <a:ext cx="2203704" cy="457200"/>
           </a:xfrm>
           <a:prstGeom prst="rect">
@@ -16049,7 +16049,7 @@
         </p:nvSpPr>
         <p:spPr>
           <a:xfrm>
-            <a:off x="9610344" y="3136392"/>
+            <a:off x="9336024" y="3154680"/>
             <a:ext cx="2203704" cy="2185416"/>
           </a:xfrm>
           <a:prstGeom prst="rect">
@@ -17400,7 +17400,117 @@
                 <a:ea typeface="Arial" pitchFamily="34" charset="-122"/>
                 <a:cs typeface="Arial" pitchFamily="34" charset="-120"/>
               </a:rPr>
-              <a:t>Usar IA será parte normal del trabajo. La ventaja está en usarla con criterio de ingeniería.</a:t>
+              <a:t>Usar IA no </a:t>
+            </a:r>
+            <a:r>
+              <a:rPr lang="en-US" sz="1700" dirty="0" err="1">
+                <a:solidFill>
+                  <a:srgbClr val="FFFFFF"/>
+                </a:solidFill>
+                <a:latin typeface="Arial" pitchFamily="34" charset="0"/>
+                <a:ea typeface="Arial" pitchFamily="34" charset="-122"/>
+                <a:cs typeface="Arial" pitchFamily="34" charset="-120"/>
+              </a:rPr>
+              <a:t>nos</a:t>
+            </a:r>
+            <a:r>
+              <a:rPr lang="en-US" sz="1700" dirty="0">
+                <a:solidFill>
+                  <a:srgbClr val="FFFFFF"/>
+                </a:solidFill>
+                <a:latin typeface="Arial" pitchFamily="34" charset="0"/>
+                <a:ea typeface="Arial" pitchFamily="34" charset="-122"/>
+                <a:cs typeface="Arial" pitchFamily="34" charset="-120"/>
+              </a:rPr>
+              <a:t> </a:t>
+            </a:r>
+            <a:r>
+              <a:rPr lang="en-US" sz="1700" dirty="0" err="1">
+                <a:solidFill>
+                  <a:srgbClr val="FFFFFF"/>
+                </a:solidFill>
+                <a:latin typeface="Arial" pitchFamily="34" charset="0"/>
+                <a:ea typeface="Arial" pitchFamily="34" charset="-122"/>
+                <a:cs typeface="Arial" pitchFamily="34" charset="-120"/>
+              </a:rPr>
+              <a:t>robará</a:t>
+            </a:r>
+            <a:r>
+              <a:rPr lang="en-US" sz="1700" dirty="0">
+                <a:solidFill>
+                  <a:srgbClr val="FFFFFF"/>
+                </a:solidFill>
+                <a:latin typeface="Arial" pitchFamily="34" charset="0"/>
+                <a:ea typeface="Arial" pitchFamily="34" charset="-122"/>
+                <a:cs typeface="Arial" pitchFamily="34" charset="-120"/>
+              </a:rPr>
+              <a:t> el </a:t>
+            </a:r>
+            <a:r>
+              <a:rPr lang="en-US" sz="1700" dirty="0" err="1">
+                <a:solidFill>
+                  <a:srgbClr val="FFFFFF"/>
+                </a:solidFill>
+                <a:latin typeface="Arial" pitchFamily="34" charset="0"/>
+                <a:ea typeface="Arial" pitchFamily="34" charset="-122"/>
+                <a:cs typeface="Arial" pitchFamily="34" charset="-120"/>
+              </a:rPr>
+              <a:t>trabajo</a:t>
+            </a:r>
+            <a:r>
+              <a:rPr lang="en-US" sz="1700" dirty="0">
+                <a:solidFill>
+                  <a:srgbClr val="FFFFFF"/>
+                </a:solidFill>
+                <a:latin typeface="Arial" pitchFamily="34" charset="0"/>
+                <a:ea typeface="Arial" pitchFamily="34" charset="-122"/>
+                <a:cs typeface="Arial" pitchFamily="34" charset="-120"/>
+              </a:rPr>
+              <a:t>, la IA </a:t>
+            </a:r>
+            <a:r>
+              <a:rPr lang="en-US" sz="1700" dirty="0" err="1">
+                <a:solidFill>
+                  <a:srgbClr val="FFFFFF"/>
+                </a:solidFill>
+                <a:latin typeface="Arial" pitchFamily="34" charset="0"/>
+                <a:ea typeface="Arial" pitchFamily="34" charset="-122"/>
+                <a:cs typeface="Arial" pitchFamily="34" charset="-120"/>
+              </a:rPr>
+              <a:t>será</a:t>
+            </a:r>
+            <a:r>
+              <a:rPr lang="en-US" sz="1700" dirty="0">
+                <a:solidFill>
+                  <a:srgbClr val="FFFFFF"/>
+                </a:solidFill>
+                <a:latin typeface="Arial" pitchFamily="34" charset="0"/>
+                <a:ea typeface="Arial" pitchFamily="34" charset="-122"/>
+                <a:cs typeface="Arial" pitchFamily="34" charset="-120"/>
+              </a:rPr>
+              <a:t> parte normal del </a:t>
+            </a:r>
+            <a:r>
+              <a:rPr lang="en-US" sz="1700" dirty="0" err="1">
+                <a:solidFill>
+                  <a:srgbClr val="FFFFFF"/>
+                </a:solidFill>
+                <a:latin typeface="Arial" pitchFamily="34" charset="0"/>
+                <a:ea typeface="Arial" pitchFamily="34" charset="-122"/>
+                <a:cs typeface="Arial" pitchFamily="34" charset="-120"/>
+              </a:rPr>
+              <a:t>mismo</a:t>
+            </a:r>
+            <a:r>
+              <a:rPr lang="en-US" sz="1700" dirty="0">
+                <a:solidFill>
+                  <a:srgbClr val="FFFFFF"/>
+                </a:solidFill>
+                <a:latin typeface="Arial" pitchFamily="34" charset="0"/>
+                <a:ea typeface="Arial" pitchFamily="34" charset="-122"/>
+                <a:cs typeface="Arial" pitchFamily="34" charset="-120"/>
+              </a:rPr>
+              <a:t>. La ventaja está en usarla con criterio de ingeniería.</a:t>
             </a:r>
             <a:endParaRPr lang="en-US" sz="1700" dirty="0"/>
           </a:p>
@@ -18018,8 +18128,118 @@
         </p:blipFill>
         <p:spPr>
           <a:xfrm>
-            <a:off x="3657600" y="990600"/>
-            <a:ext cx="4876800" cy="4876800"/>
+            <a:off x="669220" y="1498670"/>
+            <a:ext cx="3537020" cy="3537020"/>
+          </a:xfrm>
+          <a:prstGeom prst="rect">
+            <a:avLst/>
+          </a:prstGeom>
+        </p:spPr>
+      </p:pic>
+      <p:sp>
+        <p:nvSpPr>
+          <p:cNvPr id="2" name="Text 3">
+            <a:extLst>
+              <a:ext uri="{FF2B5EF4-FFF2-40B4-BE49-F238E27FC236}">
+                <a16:creationId xmlns:a16="http://schemas.microsoft.com/office/drawing/2014/main" id="{E29C7E32-D083-B05D-6085-C0CCB0673101}"/>
+              </a:ext>
+            </a:extLst>
+          </p:cNvPr>
+          <p:cNvSpPr/>
+          <p:nvPr/>
+        </p:nvSpPr>
+        <p:spPr>
+          <a:xfrm>
+            <a:off x="548640" y="5035690"/>
+            <a:ext cx="3416440" cy="548640"/>
+          </a:xfrm>
+          <a:prstGeom prst="rect">
+            <a:avLst/>
+          </a:prstGeom>
+          <a:noFill/>
+          <a:ln/>
+        </p:spPr>
+        <p:txBody>
+          <a:bodyPr wrap="square" lIns="0" tIns="0" rIns="0" bIns="0" rtlCol="0" anchor="ctr"/>
+          <a:lstStyle/>
+          <a:p>
+            <a:pPr marL="0" indent="0" algn="ctr">
+              <a:buNone/>
+            </a:pPr>
+            <a:r>
+              <a:rPr lang="en-US" sz="2200" dirty="0">
+                <a:solidFill>
+                  <a:srgbClr val="8A93A8"/>
+                </a:solidFill>
+                <a:latin typeface="Arial" pitchFamily="34" charset="0"/>
+                <a:cs typeface="Arial" pitchFamily="34" charset="-120"/>
+              </a:rPr>
+              <a:t>Repo Git</a:t>
+            </a:r>
+            <a:endParaRPr lang="en-US" sz="2200" dirty="0"/>
+          </a:p>
+        </p:txBody>
+      </p:sp>
+      <p:pic>
+        <p:nvPicPr>
+          <p:cNvPr id="8" name="Picture 7">
+            <a:extLst>
+              <a:ext uri="{FF2B5EF4-FFF2-40B4-BE49-F238E27FC236}">
+                <a16:creationId xmlns:a16="http://schemas.microsoft.com/office/drawing/2014/main" id="{CD0639CF-6733-1A00-C71B-80A6CB007E62}"/>
+              </a:ext>
+            </a:extLst>
+          </p:cNvPr>
+          <p:cNvPicPr>
+            <a:picLocks noChangeAspect="1"/>
+          </p:cNvPicPr>
+          <p:nvPr/>
+        </p:nvPicPr>
+        <p:blipFill>
+          <a:blip r:embed="rId5"/>
+          <a:stretch>
+            <a:fillRect/>
+          </a:stretch>
+        </p:blipFill>
+        <p:spPr>
+          <a:xfrm>
+            <a:off x="5705579" y="1457430"/>
+            <a:ext cx="2247900" cy="3619500"/>
+          </a:xfrm>
+          <a:prstGeom prst="rect">
+            <a:avLst/>
+          </a:prstGeom>
+        </p:spPr>
+      </p:pic>
+      <p:pic>
+        <p:nvPicPr>
+          <p:cNvPr id="10" name="Graphic 9">
+            <a:extLst>
+              <a:ext uri="{FF2B5EF4-FFF2-40B4-BE49-F238E27FC236}">
+                <a16:creationId xmlns:a16="http://schemas.microsoft.com/office/drawing/2014/main" id="{52282F34-D698-E90D-34F9-28630A8E94FE}"/>
+              </a:ext>
+            </a:extLst>
+          </p:cNvPr>
+          <p:cNvPicPr>
+            <a:picLocks noChangeAspect="1"/>
+          </p:cNvPicPr>
+          <p:nvPr/>
+        </p:nvPicPr>
+        <p:blipFill>
+          <a:blip>
+            <a:extLst>
+              <a:ext uri="{96DAC541-7B7A-43D3-8B79-37D633B846F1}">
+                <asvg:svgBlip xmlns:asvg="http://schemas.microsoft.com/office/drawing/2016/SVG/main" r:embed="rId6"/>
+              </a:ext>
+            </a:extLst>
+          </a:blip>
+          <a:stretch>
+            <a:fillRect/>
+          </a:stretch>
+        </p:blipFill>
+        <p:spPr>
+          <a:xfrm>
+            <a:off x="7953479" y="1457430"/>
+            <a:ext cx="3619500" cy="3619500"/>
           </a:xfrm>
           <a:prstGeom prst="rect">
             <a:avLst/>

</xml_diff>